<commit_message>
Update presentation slide deck to 14-slide structure
</commit_message>
<xml_diff>
--- a/Weather_Data_Analyzer_Presentation.pptx
+++ b/Weather_Data_Analyzer_Presentation.pptx
@@ -16,6 +16,9 @@
     <p:sldId id="264" r:id="rId15"/>
     <p:sldId id="265" r:id="rId16"/>
     <p:sldId id="266" r:id="rId17"/>
+    <p:sldId id="267" r:id="rId18"/>
+    <p:sldId id="268" r:id="rId19"/>
+    <p:sldId id="269" r:id="rId20"/>
   </p:sldIdLst>
   <p:sldSz cx="12191695" cy="6858000" type="screen4x3"/>
   <p:notesSz cx="6858000" cy="9144000"/>
@@ -3128,8 +3131,8 @@
           </a:bodyPr>
           <a:lstStyle/>
           <a:p>
-            <a:pPr algn="l">
-              <a:defRPr sz="4600" b="1">
+            <a:pPr>
+              <a:defRPr sz="4400" b="1">
                 <a:solidFill>
                   <a:srgbClr val="F8FAFC"/>
                 </a:solidFill>
@@ -3154,7 +3157,7 @@
         </p:nvSpPr>
         <p:spPr>
           <a:xfrm>
-            <a:off x="685800" y="3840480"/>
+            <a:off x="685800" y="3749039"/>
             <a:ext cx="10817352" cy="1645920"/>
           </a:xfrm>
           <a:prstGeom prst="rect">
@@ -3169,7 +3172,7 @@
           <a:lstStyle/>
           <a:p>
             <a:pPr>
-              <a:defRPr sz="1600">
+              <a:defRPr sz="1800" b="1">
                 <a:solidFill>
                   <a:srgbClr val="6366F1"/>
                 </a:solidFill>
@@ -3177,11 +3180,23 @@
               </a:defRPr>
             </a:pPr>
             <a:r>
-              <a:t>A Python-Tkinter Desktop Application &amp; Machine Learning Platform</a:t>
-            </a:r>
-            <a:br/>
-            <a:r>
-              <a:t>University Project Presentation | Introduction to Open Source Software</a:t>
+              <a:t>Historical Weather Analysis Using Machine Learning</a:t>
+            </a:r>
+          </a:p>
+          <a:p>
+            <a:pPr>
+              <a:spcBef>
+                <a:spcPts val="800"/>
+              </a:spcBef>
+              <a:defRPr sz="1400">
+                <a:solidFill>
+                  <a:srgbClr val="94A3B8"/>
+                </a:solidFill>
+                <a:latin typeface="Segoe UI"/>
+              </a:defRPr>
+            </a:pPr>
+            <a:r>
+              <a:t>Introduction to Open Source Software  |  University Project Presentation</a:t>
             </a:r>
           </a:p>
         </p:txBody>
@@ -3194,8 +3209,8 @@
         </p:nvSpPr>
         <p:spPr>
           <a:xfrm>
-            <a:off x="685800" y="5303520"/>
-            <a:ext cx="5486400" cy="731520"/>
+            <a:off x="685800" y="5120640"/>
+            <a:ext cx="10817352" cy="1097280"/>
           </a:xfrm>
           <a:prstGeom prst="rect">
             <a:avLst/>
@@ -3209,6 +3224,9 @@
           <a:lstStyle/>
           <a:p>
             <a:pPr>
+              <a:spcAft>
+                <a:spcPts val="400"/>
+              </a:spcAft>
               <a:defRPr sz="1100" i="1">
                 <a:solidFill>
                   <a:srgbClr val="94A3B8"/>
@@ -3217,11 +3235,15 @@
               </a:defRPr>
             </a:pPr>
             <a:r>
-              <a:t>Developer: Academic Presentation Placeholder</a:t>
+              <a:t>Student Name: [Student Name]</a:t>
             </a:r>
             <a:br/>
             <a:r>
-              <a:t>Open Source Software Course Demo</a:t>
+              <a:t>Professor Name: [Professor Name]</a:t>
+            </a:r>
+            <a:br/>
+            <a:r>
+              <a:t>University Name: [University Name]</a:t>
             </a:r>
           </a:p>
         </p:txBody>
@@ -3275,7 +3297,7 @@
           <a:lstStyle/>
           <a:p>
             <a:pPr>
-              <a:defRPr sz="3200" b="1">
+              <a:defRPr sz="3000" b="1">
                 <a:solidFill>
                   <a:srgbClr val="6366F1"/>
                 </a:solidFill>
@@ -3283,7 +3305,7 @@
               </a:defRPr>
             </a:pPr>
             <a:r>
-              <a:t>Open Source Standards &amp; Code Quality</a:t>
+              <a:t>Desktop Interface GUI Modules</a:t>
             </a:r>
           </a:p>
         </p:txBody>
@@ -3296,7 +3318,7 @@
         </p:nvSpPr>
         <p:spPr>
           <a:xfrm>
-            <a:off x="685800" y="1188720"/>
+            <a:off x="685800" y="1143000"/>
             <a:ext cx="10817352" cy="36576"/>
           </a:xfrm>
           <a:prstGeom prst="rect">
@@ -3364,7 +3386,7 @@
               </a:defRPr>
             </a:pPr>
             <a:r>
-              <a:t>Weather Data Analyzer &amp; Temperature Prediction System</a:t>
+              <a:t>Weather Data Analyzer &amp; Temperature Prediction System  |  Intro to OSS Project</a:t>
             </a:r>
           </a:p>
         </p:txBody>
@@ -3377,8 +3399,8 @@
         </p:nvSpPr>
         <p:spPr>
           <a:xfrm>
-            <a:off x="685800" y="1645920"/>
-            <a:ext cx="5120640" cy="4389120"/>
+            <a:off x="685800" y="1554480"/>
+            <a:ext cx="5120640" cy="4572000"/>
           </a:xfrm>
           <a:prstGeom prst="rect">
             <a:avLst/>
@@ -3403,71 +3425,123 @@
               </a:defRPr>
             </a:pPr>
             <a:r>
-              <a:t>Code Quality &amp; Packaging</a:t>
-            </a:r>
-          </a:p>
-          <a:p>
-            <a:pPr>
-              <a:spcAft>
-                <a:spcPts val="1000"/>
-              </a:spcAft>
-              <a:defRPr sz="1400">
-                <a:solidFill>
-                  <a:srgbClr val="94A3B8"/>
-                </a:solidFill>
-                <a:latin typeface="Segoe UI"/>
-              </a:defRPr>
-            </a:pPr>
-            <a:r>
-              <a:t>• Modular architecture separating data engines from layout managers.</a:t>
-            </a:r>
-          </a:p>
-          <a:p>
-            <a:pPr>
-              <a:spcAft>
-                <a:spcPts val="1000"/>
-              </a:spcAft>
-              <a:defRPr sz="1400">
-                <a:solidFill>
-                  <a:srgbClr val="94A3B8"/>
-                </a:solidFill>
-                <a:latin typeface="Segoe UI"/>
-              </a:defRPr>
-            </a:pPr>
-            <a:r>
-              <a:t>• Robust try-except block wrappers preventing crashes on bad cells.</a:t>
-            </a:r>
-          </a:p>
-          <a:p>
-            <a:pPr>
-              <a:spcAft>
-                <a:spcPts val="1000"/>
-              </a:spcAft>
-              <a:defRPr sz="1400">
-                <a:solidFill>
-                  <a:srgbClr val="94A3B8"/>
-                </a:solidFill>
-                <a:latin typeface="Segoe UI"/>
-              </a:defRPr>
-            </a:pPr>
-            <a:r>
-              <a:t>• Clean project directory structure: inputs in data/, plots/text in output/.</a:t>
-            </a:r>
-          </a:p>
-          <a:p>
-            <a:pPr>
-              <a:spcAft>
-                <a:spcPts val="1000"/>
-              </a:spcAft>
-              <a:defRPr sz="1400">
-                <a:solidFill>
-                  <a:srgbClr val="94A3B8"/>
-                </a:solidFill>
-                <a:latin typeface="Segoe UI"/>
-              </a:defRPr>
-            </a:pPr>
-            <a:r>
-              <a:t>• Simple installation using standard requirements.txt files.</a:t>
+              <a:t>Sidebar Controls</a:t>
+            </a:r>
+          </a:p>
+          <a:p>
+            <a:pPr>
+              <a:defRPr sz="1400" b="1">
+                <a:solidFill>
+                  <a:srgbClr val="6366F1"/>
+                </a:solidFill>
+                <a:latin typeface="Segoe UI"/>
+              </a:defRPr>
+            </a:pPr>
+            <a:r>
+              <a:t>Load Dataset</a:t>
+            </a:r>
+          </a:p>
+          <a:p>
+            <a:pPr>
+              <a:spcAft>
+                <a:spcPts val="600"/>
+              </a:spcAft>
+              <a:defRPr sz="1100">
+                <a:solidFill>
+                  <a:srgbClr val="94A3B8"/>
+                </a:solidFill>
+                <a:latin typeface="Segoe UI"/>
+              </a:defRPr>
+            </a:pPr>
+            <a:r>
+              <a:t>Allows the user to select CSV files dynamically, triggering background parser setups.</a:t>
+            </a:r>
+          </a:p>
+          <a:p>
+            <a:pPr>
+              <a:defRPr sz="1400" b="1">
+                <a:solidFill>
+                  <a:srgbClr val="6366F1"/>
+                </a:solidFill>
+                <a:latin typeface="Segoe UI"/>
+              </a:defRPr>
+            </a:pPr>
+            <a:r>
+              <a:t>Dataset Overview</a:t>
+            </a:r>
+          </a:p>
+          <a:p>
+            <a:pPr>
+              <a:spcAft>
+                <a:spcPts val="600"/>
+              </a:spcAft>
+              <a:defRPr sz="1100">
+                <a:solidFill>
+                  <a:srgbClr val="94A3B8"/>
+                </a:solidFill>
+                <a:latin typeface="Segoe UI"/>
+              </a:defRPr>
+            </a:pPr>
+            <a:r>
+              <a:t>Renders column summaries, count values, null checks, and treeview preview grids.</a:t>
+            </a:r>
+          </a:p>
+          <a:p>
+            <a:pPr>
+              <a:defRPr sz="1400" b="1">
+                <a:solidFill>
+                  <a:srgbClr val="6366F1"/>
+                </a:solidFill>
+                <a:latin typeface="Segoe UI"/>
+              </a:defRPr>
+            </a:pPr>
+            <a:r>
+              <a:t>Weather Statistics</a:t>
+            </a:r>
+          </a:p>
+          <a:p>
+            <a:pPr>
+              <a:spcAft>
+                <a:spcPts val="600"/>
+              </a:spcAft>
+              <a:defRPr sz="1100">
+                <a:solidFill>
+                  <a:srgbClr val="94A3B8"/>
+                </a:solidFill>
+                <a:latin typeface="Segoe UI"/>
+              </a:defRPr>
+            </a:pPr>
+            <a:r>
+              <a:t>Loads a cards dashboard showing minimums, maximums, totals, and averages.</a:t>
+            </a:r>
+          </a:p>
+          <a:p>
+            <a:pPr>
+              <a:defRPr sz="1400" b="1">
+                <a:solidFill>
+                  <a:srgbClr val="6366F1"/>
+                </a:solidFill>
+                <a:latin typeface="Segoe UI"/>
+              </a:defRPr>
+            </a:pPr>
+            <a:r>
+              <a:t>Generate Visualizations</a:t>
+            </a:r>
+          </a:p>
+          <a:p>
+            <a:pPr>
+              <a:spcAft>
+                <a:spcPts val="600"/>
+              </a:spcAft>
+              <a:defRPr sz="1100">
+                <a:solidFill>
+                  <a:srgbClr val="94A3B8"/>
+                </a:solidFill>
+                <a:latin typeface="Segoe UI"/>
+              </a:defRPr>
+            </a:pPr>
+            <a:r>
+              <a:t>Triggers matplotlib canvas renderings inline in the GUI window.</a:t>
             </a:r>
           </a:p>
         </p:txBody>
@@ -3480,8 +3554,8 @@
         </p:nvSpPr>
         <p:spPr>
           <a:xfrm>
-            <a:off x="6217920" y="1645920"/>
-            <a:ext cx="5120640" cy="4389120"/>
+            <a:off x="6217920" y="1554480"/>
+            <a:ext cx="5120640" cy="4572000"/>
           </a:xfrm>
           <a:prstGeom prst="rect">
             <a:avLst/>
@@ -3506,71 +3580,94 @@
               </a:defRPr>
             </a:pPr>
             <a:r>
-              <a:t>Versioning &amp; Licensing</a:t>
-            </a:r>
-          </a:p>
-          <a:p>
-            <a:pPr>
-              <a:spcAft>
-                <a:spcPts val="1000"/>
-              </a:spcAft>
-              <a:defRPr sz="1400">
-                <a:solidFill>
-                  <a:srgbClr val="94A3B8"/>
-                </a:solidFill>
-                <a:latin typeface="Segoe UI"/>
-              </a:defRPr>
-            </a:pPr>
-            <a:r>
-              <a:t>• Academic MIT License included to allow study, remixing, and redistribution.</a:t>
-            </a:r>
-          </a:p>
-          <a:p>
-            <a:pPr>
-              <a:spcAft>
-                <a:spcPts val="1000"/>
-              </a:spcAft>
-              <a:defRPr sz="1400">
-                <a:solidFill>
-                  <a:srgbClr val="94A3B8"/>
-                </a:solidFill>
-                <a:latin typeface="Segoe UI"/>
-              </a:defRPr>
-            </a:pPr>
-            <a:r>
-              <a:t>• Git configuration and .gitignore files pre-set to filter python caches.</a:t>
-            </a:r>
-          </a:p>
-          <a:p>
-            <a:pPr>
-              <a:spcAft>
-                <a:spcPts val="1000"/>
-              </a:spcAft>
-              <a:defRPr sz="1400">
-                <a:solidFill>
-                  <a:srgbClr val="94A3B8"/>
-                </a:solidFill>
-                <a:latin typeface="Segoe UI"/>
-              </a:defRPr>
-            </a:pPr>
-            <a:r>
-              <a:t>• Project repository fully committed and pushed to remote GitHub repository.</a:t>
-            </a:r>
-          </a:p>
-          <a:p>
-            <a:pPr>
-              <a:spcAft>
-                <a:spcPts val="1000"/>
-              </a:spcAft>
-              <a:defRPr sz="1400">
-                <a:solidFill>
-                  <a:srgbClr val="94A3B8"/>
-                </a:solidFill>
-                <a:latin typeface="Segoe UI"/>
-              </a:defRPr>
-            </a:pPr>
-            <a:r>
-              <a:t>• Detailed README.md documenting system architecture and libraries.</a:t>
+              <a:t>Model Controls</a:t>
+            </a:r>
+          </a:p>
+          <a:p>
+            <a:pPr>
+              <a:defRPr sz="1400" b="1">
+                <a:solidFill>
+                  <a:srgbClr val="10B981"/>
+                </a:solidFill>
+                <a:latin typeface="Segoe UI"/>
+              </a:defRPr>
+            </a:pPr>
+            <a:r>
+              <a:t>Train Model</a:t>
+            </a:r>
+          </a:p>
+          <a:p>
+            <a:pPr>
+              <a:spcAft>
+                <a:spcPts val="600"/>
+              </a:spcAft>
+              <a:defRPr sz="1100">
+                <a:solidFill>
+                  <a:srgbClr val="94A3B8"/>
+                </a:solidFill>
+                <a:latin typeface="Segoe UI"/>
+              </a:defRPr>
+            </a:pPr>
+            <a:r>
+              <a:t>Fits regression equations and displays features list, intercepts, and intercepts weights.</a:t>
+            </a:r>
+          </a:p>
+          <a:p>
+            <a:pPr>
+              <a:defRPr sz="1400" b="1">
+                <a:solidFill>
+                  <a:srgbClr val="10B981"/>
+                </a:solidFill>
+                <a:latin typeface="Segoe UI"/>
+              </a:defRPr>
+            </a:pPr>
+            <a:r>
+              <a:t>Predict Temperature</a:t>
+            </a:r>
+          </a:p>
+          <a:p>
+            <a:pPr>
+              <a:spcAft>
+                <a:spcPts val="600"/>
+              </a:spcAft>
+              <a:defRPr sz="1100">
+                <a:solidFill>
+                  <a:srgbClr val="94A3B8"/>
+                </a:solidFill>
+                <a:latin typeface="Segoe UI"/>
+              </a:defRPr>
+            </a:pPr>
+            <a:r>
+              <a:t>Renders input fields dynamically based on features. Outputs predictions using color-coded badges (Blue for cold, Green for moderate, Red for hot).</a:t>
+            </a:r>
+          </a:p>
+          <a:p>
+            <a:pPr>
+              <a:defRPr sz="1400" b="1">
+                <a:solidFill>
+                  <a:srgbClr val="10B981"/>
+                </a:solidFill>
+                <a:latin typeface="Segoe UI"/>
+              </a:defRPr>
+            </a:pPr>
+            <a:r>
+              <a:t>Generate Report</a:t>
+            </a:r>
+          </a:p>
+          <a:p>
+            <a:pPr>
+              <a:spcAft>
+                <a:spcPts val="600"/>
+              </a:spcAft>
+              <a:defRPr sz="1100">
+                <a:solidFill>
+                  <a:srgbClr val="94A3B8"/>
+                </a:solidFill>
+                <a:latin typeface="Segoe UI"/>
+              </a:defRPr>
+            </a:pPr>
+            <a:r>
+              <a:t>Outputs analytical reports into a scrollable read-only text viewer pane.</a:t>
             </a:r>
           </a:p>
         </p:txBody>
@@ -3624,7 +3721,7 @@
           <a:lstStyle/>
           <a:p>
             <a:pPr>
-              <a:defRPr sz="3200" b="1">
+              <a:defRPr sz="3000" b="1">
                 <a:solidFill>
                   <a:srgbClr val="6366F1"/>
                 </a:solidFill>
@@ -3632,7 +3729,7 @@
               </a:defRPr>
             </a:pPr>
             <a:r>
-              <a:t>Conclusion &amp; Future Scope</a:t>
+              <a:t>Open Source Project Files</a:t>
             </a:r>
           </a:p>
         </p:txBody>
@@ -3645,7 +3742,7 @@
         </p:nvSpPr>
         <p:spPr>
           <a:xfrm>
-            <a:off x="685800" y="1188720"/>
+            <a:off x="685800" y="1143000"/>
             <a:ext cx="10817352" cy="36576"/>
           </a:xfrm>
           <a:prstGeom prst="rect">
@@ -3713,7 +3810,7 @@
               </a:defRPr>
             </a:pPr>
             <a:r>
-              <a:t>Weather Data Analyzer &amp; Temperature Prediction System</a:t>
+              <a:t>Weather Data Analyzer &amp; Temperature Prediction System  |  Intro to OSS Project</a:t>
             </a:r>
           </a:p>
         </p:txBody>
@@ -3726,8 +3823,8 @@
         </p:nvSpPr>
         <p:spPr>
           <a:xfrm>
-            <a:off x="685800" y="1645920"/>
-            <a:ext cx="5120640" cy="4389120"/>
+            <a:off x="685800" y="1554480"/>
+            <a:ext cx="5120640" cy="4572000"/>
           </a:xfrm>
           <a:prstGeom prst="rect">
             <a:avLst/>
@@ -3752,12 +3849,12 @@
               </a:defRPr>
             </a:pPr>
             <a:r>
-              <a:t>Future Roadmap</a:t>
-            </a:r>
-          </a:p>
-          <a:p>
-            <a:pPr>
-              <a:defRPr sz="1400" b="1">
+              <a:t>Core Repository Documentation</a:t>
+            </a:r>
+          </a:p>
+          <a:p>
+            <a:pPr>
+              <a:defRPr sz="1500" b="1">
                 <a:solidFill>
                   <a:srgbClr val="6366F1"/>
                 </a:solidFill>
@@ -3765,13 +3862,13 @@
               </a:defRPr>
             </a:pPr>
             <a:r>
-              <a:t>Advanced ML Algorithms</a:t>
-            </a:r>
-          </a:p>
-          <a:p>
-            <a:pPr>
-              <a:spcAft>
-                <a:spcPts val="600"/>
+              <a:t>README.md</a:t>
+            </a:r>
+          </a:p>
+          <a:p>
+            <a:pPr>
+              <a:spcAft>
+                <a:spcPts val="1000"/>
               </a:spcAft>
               <a:defRPr sz="1200">
                 <a:solidFill>
@@ -3781,12 +3878,12 @@
               </a:defRPr>
             </a:pPr>
             <a:r>
-              <a:t>Support Random Forest, XGBoost, or time-series (LSTM) prediction engines.</a:t>
-            </a:r>
-          </a:p>
-          <a:p>
-            <a:pPr>
-              <a:defRPr sz="1400" b="1">
+              <a:t>Provides user documentation including setup requirements, execution guides, workflow charts, visual catalogs, and project structures.</a:t>
+            </a:r>
+          </a:p>
+          <a:p>
+            <a:pPr>
+              <a:defRPr sz="1500" b="1">
                 <a:solidFill>
                   <a:srgbClr val="6366F1"/>
                 </a:solidFill>
@@ -3794,13 +3891,13 @@
               </a:defRPr>
             </a:pPr>
             <a:r>
-              <a:t>Live API Integrations</a:t>
-            </a:r>
-          </a:p>
-          <a:p>
-            <a:pPr>
-              <a:spcAft>
-                <a:spcPts val="600"/>
+              <a:t>requirements.txt</a:t>
+            </a:r>
+          </a:p>
+          <a:p>
+            <a:pPr>
+              <a:spcAft>
+                <a:spcPts val="1000"/>
               </a:spcAft>
               <a:defRPr sz="1200">
                 <a:solidFill>
@@ -3810,12 +3907,12 @@
               </a:defRPr>
             </a:pPr>
             <a:r>
-              <a:t>Fetch real-time weather stats from OpenWeatherMap to predict immediate local temp shifts.</a:t>
-            </a:r>
-          </a:p>
-          <a:p>
-            <a:pPr>
-              <a:defRPr sz="1400" b="1">
+              <a:t>Specifies external dependency lists (scikit-learn, pandas, seaborn, matplotlib) to ensure reproducible installs.</a:t>
+            </a:r>
+          </a:p>
+          <a:p>
+            <a:pPr>
+              <a:defRPr sz="1500" b="1">
                 <a:solidFill>
                   <a:srgbClr val="6366F1"/>
                 </a:solidFill>
@@ -3823,13 +3920,13 @@
               </a:defRPr>
             </a:pPr>
             <a:r>
-              <a:t>Report Extensions</a:t>
-            </a:r>
-          </a:p>
-          <a:p>
-            <a:pPr>
-              <a:spcAft>
-                <a:spcPts val="600"/>
+              <a:t>LICENSE</a:t>
+            </a:r>
+          </a:p>
+          <a:p>
+            <a:pPr>
+              <a:spcAft>
+                <a:spcPts val="1000"/>
               </a:spcAft>
               <a:defRPr sz="1200">
                 <a:solidFill>
@@ -3839,7 +3936,7 @@
               </a:defRPr>
             </a:pPr>
             <a:r>
-              <a:t>Render and compile weather reports to formatted PDF tables.</a:t>
+              <a:t>Establishes legal rights. Uses the permissive MIT License, permitting modification, redistribution, and academic usage.</a:t>
             </a:r>
           </a:p>
         </p:txBody>
@@ -3852,8 +3949,8 @@
         </p:nvSpPr>
         <p:spPr>
           <a:xfrm>
-            <a:off x="6217920" y="1645920"/>
-            <a:ext cx="5120640" cy="4389120"/>
+            <a:off x="6217920" y="1554480"/>
+            <a:ext cx="5120640" cy="4572000"/>
           </a:xfrm>
           <a:prstGeom prst="rect">
             <a:avLst/>
@@ -3878,7 +3975,7 @@
               </a:defRPr>
             </a:pPr>
             <a:r>
-              <a:t>Summary &amp; Q&amp;A</a:t>
+              <a:t>Open Source Value</a:t>
             </a:r>
           </a:p>
           <a:p>
@@ -3894,7 +3991,7 @@
               </a:defRPr>
             </a:pPr>
             <a:r>
-              <a:t>• Successfully delivered a clean, desktop weather analyzer application.</a:t>
+              <a:t>• Promotes transparency by sharing full execution code.</a:t>
             </a:r>
           </a:p>
           <a:p>
@@ -3910,7 +4007,7 @@
               </a:defRPr>
             </a:pPr>
             <a:r>
-              <a:t>• Demonstrates structured modular designs, clean documentation, and regression splits.</a:t>
+              <a:t>• Guarantees scientific reproducibility of ML predictions.</a:t>
             </a:r>
           </a:p>
           <a:p>
@@ -3926,23 +4023,885 @@
               </a:defRPr>
             </a:pPr>
             <a:r>
-              <a:t>• Perfect educational framework for open-source study.</a:t>
-            </a:r>
-          </a:p>
-          <a:p>
-            <a:pPr>
+              <a:t>• Enables community peer reviews and fork modifications.</a:t>
+            </a:r>
+          </a:p>
+          <a:p>
+            <a:pPr>
+              <a:spcAft>
+                <a:spcPts val="1000"/>
+              </a:spcAft>
+              <a:defRPr sz="1400">
+                <a:solidFill>
+                  <a:srgbClr val="94A3B8"/>
+                </a:solidFill>
+                <a:latin typeface="Segoe UI"/>
+              </a:defRPr>
+            </a:pPr>
+            <a:r>
+              <a:t>• Establishes clean repository guidelines for collaborative university submissions.</a:t>
+            </a:r>
+          </a:p>
+        </p:txBody>
+      </p:sp>
+    </p:spTree>
+  </p:cSld>
+  <p:clrMapOvr>
+    <a:masterClrMapping/>
+  </p:clrMapOvr>
+</p:sld>
+</file>
+
+<file path=ppt/slides/slide12.xml><?xml version="1.0" encoding="utf-8"?>
+<p:sld xmlns:a="http://schemas.openxmlformats.org/drawingml/2006/main" xmlns:p="http://schemas.openxmlformats.org/presentationml/2006/main" xmlns:r="http://schemas.openxmlformats.org/officeDocument/2006/relationships">
+  <p:cSld>
+    <p:bg>
+      <p:bgPr>
+        <a:solidFill>
+          <a:srgbClr val="0F172A"/>
+        </a:solidFill>
+        <a:effectLst/>
+      </p:bgPr>
+    </p:bg>
+    <p:spTree>
+      <p:nvGrpSpPr>
+        <p:cNvPr id="1" name=""/>
+        <p:cNvGrpSpPr/>
+        <p:nvPr/>
+      </p:nvGrpSpPr>
+      <p:grpSpPr/>
+      <p:sp>
+        <p:nvSpPr>
+          <p:cNvPr id="2" name="TextBox 1"/>
+          <p:cNvSpPr txBox="1"/>
+          <p:nvPr/>
+        </p:nvSpPr>
+        <p:spPr>
+          <a:xfrm>
+            <a:off x="685800" y="457200"/>
+            <a:ext cx="10817352" cy="731520"/>
+          </a:xfrm>
+          <a:prstGeom prst="rect">
+            <a:avLst/>
+          </a:prstGeom>
+          <a:noFill/>
+        </p:spPr>
+        <p:txBody>
+          <a:bodyPr wrap="square" tIns="0" bIns="0" lIns="0" rIns="0">
+            <a:spAutoFit/>
+          </a:bodyPr>
+          <a:lstStyle/>
+          <a:p>
+            <a:pPr>
+              <a:defRPr sz="3000" b="1">
+                <a:solidFill>
+                  <a:srgbClr val="6366F1"/>
+                </a:solidFill>
+                <a:latin typeface="Segoe UI"/>
+              </a:defRPr>
+            </a:pPr>
+            <a:r>
+              <a:t>Project Structure &amp; Execution</a:t>
+            </a:r>
+          </a:p>
+        </p:txBody>
+      </p:sp>
+      <p:sp>
+        <p:nvSpPr>
+          <p:cNvPr id="3" name="Rectangle 2"/>
+          <p:cNvSpPr/>
+          <p:nvPr/>
+        </p:nvSpPr>
+        <p:spPr>
+          <a:xfrm>
+            <a:off x="685800" y="1143000"/>
+            <a:ext cx="10817352" cy="36576"/>
+          </a:xfrm>
+          <a:prstGeom prst="rect">
+            <a:avLst/>
+          </a:prstGeom>
+          <a:solidFill>
+            <a:srgbClr val="6366F1"/>
+          </a:solidFill>
+          <a:ln>
+            <a:solidFill>
+              <a:srgbClr val="6366F1"/>
+            </a:solidFill>
+          </a:ln>
+        </p:spPr>
+        <p:style>
+          <a:lnRef idx="1">
+            <a:schemeClr val="accent1"/>
+          </a:lnRef>
+          <a:fillRef idx="3">
+            <a:schemeClr val="accent1"/>
+          </a:fillRef>
+          <a:effectRef idx="2">
+            <a:schemeClr val="accent1"/>
+          </a:effectRef>
+          <a:fontRef idx="minor">
+            <a:schemeClr val="lt1"/>
+          </a:fontRef>
+        </p:style>
+        <p:txBody>
+          <a:bodyPr rtlCol="0" anchor="ctr"/>
+          <a:lstStyle/>
+          <a:p>
+            <a:pPr algn="ctr"/>
+          </a:p>
+        </p:txBody>
+      </p:sp>
+      <p:sp>
+        <p:nvSpPr>
+          <p:cNvPr id="4" name="TextBox 3"/>
+          <p:cNvSpPr txBox="1"/>
+          <p:nvPr/>
+        </p:nvSpPr>
+        <p:spPr>
+          <a:xfrm>
+            <a:off x="685800" y="6400800"/>
+            <a:ext cx="10817352" cy="274320"/>
+          </a:xfrm>
+          <a:prstGeom prst="rect">
+            <a:avLst/>
+          </a:prstGeom>
+          <a:noFill/>
+        </p:spPr>
+        <p:txBody>
+          <a:bodyPr wrap="none">
+            <a:spAutoFit/>
+          </a:bodyPr>
+          <a:lstStyle/>
+          <a:p>
+            <a:pPr>
+              <a:defRPr sz="900">
+                <a:solidFill>
+                  <a:srgbClr val="94A3B8"/>
+                </a:solidFill>
+                <a:latin typeface="Segoe UI"/>
+              </a:defRPr>
+            </a:pPr>
+            <a:r>
+              <a:t>Weather Data Analyzer &amp; Temperature Prediction System  |  Intro to OSS Project</a:t>
+            </a:r>
+          </a:p>
+        </p:txBody>
+      </p:sp>
+      <p:sp>
+        <p:nvSpPr>
+          <p:cNvPr id="5" name="TextBox 4"/>
+          <p:cNvSpPr txBox="1"/>
+          <p:nvPr/>
+        </p:nvSpPr>
+        <p:spPr>
+          <a:xfrm>
+            <a:off x="685800" y="1554480"/>
+            <a:ext cx="5120640" cy="4572000"/>
+          </a:xfrm>
+          <a:prstGeom prst="rect">
+            <a:avLst/>
+          </a:prstGeom>
+          <a:noFill/>
+        </p:spPr>
+        <p:txBody>
+          <a:bodyPr wrap="square">
+            <a:spAutoFit/>
+          </a:bodyPr>
+          <a:lstStyle/>
+          <a:p>
+            <a:pPr>
+              <a:spcAft>
+                <a:spcPts val="1200"/>
+              </a:spcAft>
+              <a:defRPr sz="2000" b="1">
+                <a:solidFill>
+                  <a:srgbClr val="F8FAFC"/>
+                </a:solidFill>
+                <a:latin typeface="Segoe UI"/>
+              </a:defRPr>
+            </a:pPr>
+            <a:r>
+              <a:t>Folder Structure Layout</a:t>
+            </a:r>
+          </a:p>
+          <a:p>
+            <a:pPr>
+              <a:spcAft>
+                <a:spcPts val="1000"/>
+              </a:spcAft>
+              <a:defRPr sz="1100">
+                <a:solidFill>
+                  <a:srgbClr val="94A3B8"/>
+                </a:solidFill>
+                <a:latin typeface="Consolas"/>
+              </a:defRPr>
+            </a:pPr>
+            <a:r>
+              <a:t>weather-data-analyzer/</a:t>
+            </a:r>
+            <a:br/>
+            <a:r>
+              <a:t>├── data/</a:t>
+            </a:r>
+            <a:br/>
+            <a:r>
+              <a:t>│   ├── seoul_weather_2022_to_2024.csv</a:t>
+            </a:r>
+            <a:br/>
+            <a:r>
+              <a:t>│   └── london_weather_sample.csv</a:t>
+            </a:r>
+            <a:br/>
+            <a:r>
+              <a:t>├── output/</a:t>
+            </a:r>
+            <a:br/>
+            <a:r>
+              <a:t>│   ├── temperature_trend.png</a:t>
+            </a:r>
+            <a:br/>
+            <a:r>
+              <a:t>│   ├── actual_vs_predicted.png</a:t>
+            </a:r>
+            <a:br/>
+            <a:r>
+              <a:t>│   └── weather_report.txt</a:t>
+            </a:r>
+            <a:br/>
+            <a:r>
+              <a:t>├── main.py</a:t>
+            </a:r>
+            <a:br/>
+            <a:r>
+              <a:t>├── requirements.txt</a:t>
+            </a:r>
+            <a:br/>
+            <a:r>
+              <a:t>├── LICENSE</a:t>
+            </a:r>
+            <a:br/>
+            <a:r>
+              <a:t>└── README.md</a:t>
+            </a:r>
+          </a:p>
+        </p:txBody>
+      </p:sp>
+      <p:sp>
+        <p:nvSpPr>
+          <p:cNvPr id="6" name="TextBox 5"/>
+          <p:cNvSpPr txBox="1"/>
+          <p:nvPr/>
+        </p:nvSpPr>
+        <p:spPr>
+          <a:xfrm>
+            <a:off x="6217920" y="1554480"/>
+            <a:ext cx="5120640" cy="4572000"/>
+          </a:xfrm>
+          <a:prstGeom prst="rect">
+            <a:avLst/>
+          </a:prstGeom>
+          <a:noFill/>
+        </p:spPr>
+        <p:txBody>
+          <a:bodyPr wrap="square">
+            <a:spAutoFit/>
+          </a:bodyPr>
+          <a:lstStyle/>
+          <a:p>
+            <a:pPr>
+              <a:spcAft>
+                <a:spcPts val="1200"/>
+              </a:spcAft>
+              <a:defRPr sz="2000" b="1">
+                <a:solidFill>
+                  <a:srgbClr val="F8FAFC"/>
+                </a:solidFill>
+                <a:latin typeface="Segoe UI"/>
+              </a:defRPr>
+            </a:pPr>
+            <a:r>
+              <a:t>System Launch Commands</a:t>
+            </a:r>
+          </a:p>
+          <a:p>
+            <a:pPr>
+              <a:defRPr sz="1300" b="1">
+                <a:solidFill>
+                  <a:srgbClr val="10B981"/>
+                </a:solidFill>
+                <a:latin typeface="Segoe UI"/>
+              </a:defRPr>
+            </a:pPr>
+            <a:r>
+              <a:t>1. Clone Repository</a:t>
+            </a:r>
+          </a:p>
+          <a:p>
+            <a:pPr>
+              <a:spcAft>
+                <a:spcPts val="600"/>
+              </a:spcAft>
+              <a:defRPr sz="950">
+                <a:solidFill>
+                  <a:srgbClr val="94A3B8"/>
+                </a:solidFill>
+                <a:latin typeface="Consolas"/>
+              </a:defRPr>
+            </a:pPr>
+            <a:r>
+              <a:t>git clone https://github.com/aperfectrio/weather-data-analyzer-and-prediction.git</a:t>
+            </a:r>
+            <a:br/>
+            <a:r>
+              <a:t>cd weather-data-analyzer-and-prediction</a:t>
+            </a:r>
+          </a:p>
+          <a:p>
+            <a:pPr>
+              <a:defRPr sz="1300" b="1">
+                <a:solidFill>
+                  <a:srgbClr val="10B981"/>
+                </a:solidFill>
+                <a:latin typeface="Segoe UI"/>
+              </a:defRPr>
+            </a:pPr>
+            <a:r>
+              <a:t>2. Install Dependencies</a:t>
+            </a:r>
+          </a:p>
+          <a:p>
+            <a:pPr>
+              <a:spcAft>
+                <a:spcPts val="600"/>
+              </a:spcAft>
+              <a:defRPr sz="950">
+                <a:solidFill>
+                  <a:srgbClr val="94A3B8"/>
+                </a:solidFill>
+                <a:latin typeface="Consolas"/>
+              </a:defRPr>
+            </a:pPr>
+            <a:r>
+              <a:t>pip install -r requirements.txt</a:t>
+            </a:r>
+          </a:p>
+          <a:p>
+            <a:pPr>
+              <a:defRPr sz="1300" b="1">
+                <a:solidFill>
+                  <a:srgbClr val="10B981"/>
+                </a:solidFill>
+                <a:latin typeface="Segoe UI"/>
+              </a:defRPr>
+            </a:pPr>
+            <a:r>
+              <a:t>3. Execute Interface Application</a:t>
+            </a:r>
+          </a:p>
+          <a:p>
+            <a:pPr>
+              <a:spcAft>
+                <a:spcPts val="600"/>
+              </a:spcAft>
+              <a:defRPr sz="950">
+                <a:solidFill>
+                  <a:srgbClr val="94A3B8"/>
+                </a:solidFill>
+                <a:latin typeface="Consolas"/>
+              </a:defRPr>
+            </a:pPr>
+            <a:r>
+              <a:t>python main.py</a:t>
+            </a:r>
+          </a:p>
+        </p:txBody>
+      </p:sp>
+    </p:spTree>
+  </p:cSld>
+  <p:clrMapOvr>
+    <a:masterClrMapping/>
+  </p:clrMapOvr>
+</p:sld>
+</file>
+
+<file path=ppt/slides/slide13.xml><?xml version="1.0" encoding="utf-8"?>
+<p:sld xmlns:a="http://schemas.openxmlformats.org/drawingml/2006/main" xmlns:p="http://schemas.openxmlformats.org/presentationml/2006/main" xmlns:r="http://schemas.openxmlformats.org/officeDocument/2006/relationships">
+  <p:cSld>
+    <p:bg>
+      <p:bgPr>
+        <a:solidFill>
+          <a:srgbClr val="0F172A"/>
+        </a:solidFill>
+        <a:effectLst/>
+      </p:bgPr>
+    </p:bg>
+    <p:spTree>
+      <p:nvGrpSpPr>
+        <p:cNvPr id="1" name=""/>
+        <p:cNvGrpSpPr/>
+        <p:nvPr/>
+      </p:nvGrpSpPr>
+      <p:grpSpPr/>
+      <p:sp>
+        <p:nvSpPr>
+          <p:cNvPr id="2" name="TextBox 1"/>
+          <p:cNvSpPr txBox="1"/>
+          <p:nvPr/>
+        </p:nvSpPr>
+        <p:spPr>
+          <a:xfrm>
+            <a:off x="685800" y="457200"/>
+            <a:ext cx="10817352" cy="731520"/>
+          </a:xfrm>
+          <a:prstGeom prst="rect">
+            <a:avLst/>
+          </a:prstGeom>
+          <a:noFill/>
+        </p:spPr>
+        <p:txBody>
+          <a:bodyPr wrap="square" tIns="0" bIns="0" lIns="0" rIns="0">
+            <a:spAutoFit/>
+          </a:bodyPr>
+          <a:lstStyle/>
+          <a:p>
+            <a:pPr>
+              <a:defRPr sz="3000" b="1">
+                <a:solidFill>
+                  <a:srgbClr val="6366F1"/>
+                </a:solidFill>
+                <a:latin typeface="Segoe UI"/>
+              </a:defRPr>
+            </a:pPr>
+            <a:r>
+              <a:t>Summary, Conclusions &amp; Future Scope</a:t>
+            </a:r>
+          </a:p>
+        </p:txBody>
+      </p:sp>
+      <p:sp>
+        <p:nvSpPr>
+          <p:cNvPr id="3" name="Rectangle 2"/>
+          <p:cNvSpPr/>
+          <p:nvPr/>
+        </p:nvSpPr>
+        <p:spPr>
+          <a:xfrm>
+            <a:off x="685800" y="1143000"/>
+            <a:ext cx="10817352" cy="36576"/>
+          </a:xfrm>
+          <a:prstGeom prst="rect">
+            <a:avLst/>
+          </a:prstGeom>
+          <a:solidFill>
+            <a:srgbClr val="6366F1"/>
+          </a:solidFill>
+          <a:ln>
+            <a:solidFill>
+              <a:srgbClr val="6366F1"/>
+            </a:solidFill>
+          </a:ln>
+        </p:spPr>
+        <p:style>
+          <a:lnRef idx="1">
+            <a:schemeClr val="accent1"/>
+          </a:lnRef>
+          <a:fillRef idx="3">
+            <a:schemeClr val="accent1"/>
+          </a:fillRef>
+          <a:effectRef idx="2">
+            <a:schemeClr val="accent1"/>
+          </a:effectRef>
+          <a:fontRef idx="minor">
+            <a:schemeClr val="lt1"/>
+          </a:fontRef>
+        </p:style>
+        <p:txBody>
+          <a:bodyPr rtlCol="0" anchor="ctr"/>
+          <a:lstStyle/>
+          <a:p>
+            <a:pPr algn="ctr"/>
+          </a:p>
+        </p:txBody>
+      </p:sp>
+      <p:sp>
+        <p:nvSpPr>
+          <p:cNvPr id="4" name="TextBox 3"/>
+          <p:cNvSpPr txBox="1"/>
+          <p:nvPr/>
+        </p:nvSpPr>
+        <p:spPr>
+          <a:xfrm>
+            <a:off x="685800" y="6400800"/>
+            <a:ext cx="10817352" cy="274320"/>
+          </a:xfrm>
+          <a:prstGeom prst="rect">
+            <a:avLst/>
+          </a:prstGeom>
+          <a:noFill/>
+        </p:spPr>
+        <p:txBody>
+          <a:bodyPr wrap="none">
+            <a:spAutoFit/>
+          </a:bodyPr>
+          <a:lstStyle/>
+          <a:p>
+            <a:pPr>
+              <a:defRPr sz="900">
+                <a:solidFill>
+                  <a:srgbClr val="94A3B8"/>
+                </a:solidFill>
+                <a:latin typeface="Segoe UI"/>
+              </a:defRPr>
+            </a:pPr>
+            <a:r>
+              <a:t>Weather Data Analyzer &amp; Temperature Prediction System  |  Intro to OSS Project</a:t>
+            </a:r>
+          </a:p>
+        </p:txBody>
+      </p:sp>
+      <p:sp>
+        <p:nvSpPr>
+          <p:cNvPr id="5" name="TextBox 4"/>
+          <p:cNvSpPr txBox="1"/>
+          <p:nvPr/>
+        </p:nvSpPr>
+        <p:spPr>
+          <a:xfrm>
+            <a:off x="685800" y="1554480"/>
+            <a:ext cx="5120640" cy="4572000"/>
+          </a:xfrm>
+          <a:prstGeom prst="rect">
+            <a:avLst/>
+          </a:prstGeom>
+          <a:noFill/>
+        </p:spPr>
+        <p:txBody>
+          <a:bodyPr wrap="square">
+            <a:spAutoFit/>
+          </a:bodyPr>
+          <a:lstStyle/>
+          <a:p>
+            <a:pPr>
+              <a:spcAft>
+                <a:spcPts val="1200"/>
+              </a:spcAft>
+              <a:defRPr sz="2000" b="1">
+                <a:solidFill>
+                  <a:srgbClr val="F8FAFC"/>
+                </a:solidFill>
+                <a:latin typeface="Segoe UI"/>
+              </a:defRPr>
+            </a:pPr>
+            <a:r>
+              <a:t>System Summary</a:t>
+            </a:r>
+          </a:p>
+          <a:p>
+            <a:pPr>
+              <a:spcAft>
+                <a:spcPts val="800"/>
+              </a:spcAft>
+              <a:defRPr sz="1300">
+                <a:solidFill>
+                  <a:srgbClr val="94A3B8"/>
+                </a:solidFill>
+                <a:latin typeface="Segoe UI"/>
+              </a:defRPr>
+            </a:pPr>
+            <a:r>
+              <a:t>• Built a complete data analysis desktop app with an interactive Tkinter GUI.</a:t>
+            </a:r>
+          </a:p>
+          <a:p>
+            <a:pPr>
+              <a:spcAft>
+                <a:spcPts val="800"/>
+              </a:spcAft>
+              <a:defRPr sz="1300">
+                <a:solidFill>
+                  <a:srgbClr val="94A3B8"/>
+                </a:solidFill>
+                <a:latin typeface="Segoe UI"/>
+              </a:defRPr>
+            </a:pPr>
+            <a:r>
+              <a:t>• Demonstrated automated regex column detectors, data preprocessing, and descriptive statistical calculation capabilities.</a:t>
+            </a:r>
+          </a:p>
+          <a:p>
+            <a:pPr>
+              <a:spcAft>
+                <a:spcPts val="800"/>
+              </a:spcAft>
+              <a:defRPr sz="1300">
+                <a:solidFill>
+                  <a:srgbClr val="94A3B8"/>
+                </a:solidFill>
+                <a:latin typeface="Segoe UI"/>
+              </a:defRPr>
+            </a:pPr>
+            <a:r>
+              <a:t>• Created an OLS Linear Regression forecasting engine with local model serialization.</a:t>
+            </a:r>
+          </a:p>
+          <a:p>
+            <a:pPr>
+              <a:spcAft>
+                <a:spcPts val="800"/>
+              </a:spcAft>
+              <a:defRPr sz="1300">
+                <a:solidFill>
+                  <a:srgbClr val="94A3B8"/>
+                </a:solidFill>
+                <a:latin typeface="Segoe UI"/>
+              </a:defRPr>
+            </a:pPr>
+            <a:r>
+              <a:t>• Implemented open-source versioning, licensing, and documentation standards.</a:t>
+            </a:r>
+          </a:p>
+        </p:txBody>
+      </p:sp>
+      <p:sp>
+        <p:nvSpPr>
+          <p:cNvPr id="6" name="TextBox 5"/>
+          <p:cNvSpPr txBox="1"/>
+          <p:nvPr/>
+        </p:nvSpPr>
+        <p:spPr>
+          <a:xfrm>
+            <a:off x="6217920" y="1554480"/>
+            <a:ext cx="5120640" cy="4572000"/>
+          </a:xfrm>
+          <a:prstGeom prst="rect">
+            <a:avLst/>
+          </a:prstGeom>
+          <a:noFill/>
+        </p:spPr>
+        <p:txBody>
+          <a:bodyPr wrap="square">
+            <a:spAutoFit/>
+          </a:bodyPr>
+          <a:lstStyle/>
+          <a:p>
+            <a:pPr>
+              <a:spcAft>
+                <a:spcPts val="1200"/>
+              </a:spcAft>
+              <a:defRPr sz="2000" b="1">
+                <a:solidFill>
+                  <a:srgbClr val="F8FAFC"/>
+                </a:solidFill>
+                <a:latin typeface="Segoe UI"/>
+              </a:defRPr>
+            </a:pPr>
+            <a:r>
+              <a:t>Future Roadmap</a:t>
+            </a:r>
+          </a:p>
+          <a:p>
+            <a:pPr>
+              <a:defRPr sz="1400" b="1">
+                <a:solidFill>
+                  <a:srgbClr val="6366F1"/>
+                </a:solidFill>
+                <a:latin typeface="Segoe UI"/>
+              </a:defRPr>
+            </a:pPr>
+            <a:r>
+              <a:t>Advanced Predictions</a:t>
+            </a:r>
+          </a:p>
+          <a:p>
+            <a:pPr>
+              <a:spcAft>
+                <a:spcPts val="600"/>
+              </a:spcAft>
+              <a:defRPr sz="1200">
+                <a:solidFill>
+                  <a:srgbClr val="94A3B8"/>
+                </a:solidFill>
+                <a:latin typeface="Segoe UI"/>
+              </a:defRPr>
+            </a:pPr>
+            <a:r>
+              <a:t>Implement non-linear regression models (Random Forest, Gradient Boosting).</a:t>
+            </a:r>
+          </a:p>
+          <a:p>
+            <a:pPr>
+              <a:defRPr sz="1400" b="1">
+                <a:solidFill>
+                  <a:srgbClr val="6366F1"/>
+                </a:solidFill>
+                <a:latin typeface="Segoe UI"/>
+              </a:defRPr>
+            </a:pPr>
+            <a:r>
+              <a:t>Live API Feeds</a:t>
+            </a:r>
+          </a:p>
+          <a:p>
+            <a:pPr>
+              <a:spcAft>
+                <a:spcPts val="600"/>
+              </a:spcAft>
+              <a:defRPr sz="1200">
+                <a:solidFill>
+                  <a:srgbClr val="94A3B8"/>
+                </a:solidFill>
+                <a:latin typeface="Segoe UI"/>
+              </a:defRPr>
+            </a:pPr>
+            <a:r>
+              <a:t>Fetch real-time weather datasets from public APIs (e.g. OpenWeatherMap) directly in-app.</a:t>
+            </a:r>
+          </a:p>
+          <a:p>
+            <a:pPr>
+              <a:defRPr sz="1400" b="1">
+                <a:solidFill>
+                  <a:srgbClr val="6366F1"/>
+                </a:solidFill>
+                <a:latin typeface="Segoe UI"/>
+              </a:defRPr>
+            </a:pPr>
+            <a:r>
+              <a:t>Analytical PDF Exporter</a:t>
+            </a:r>
+          </a:p>
+          <a:p>
+            <a:pPr>
+              <a:spcAft>
+                <a:spcPts val="600"/>
+              </a:spcAft>
+              <a:defRPr sz="1200">
+                <a:solidFill>
+                  <a:srgbClr val="94A3B8"/>
+                </a:solidFill>
+                <a:latin typeface="Segoe UI"/>
+              </a:defRPr>
+            </a:pPr>
+            <a:r>
+              <a:t>Expand report generator utilities to export formatted PDF document sheets.</a:t>
+            </a:r>
+          </a:p>
+        </p:txBody>
+      </p:sp>
+    </p:spTree>
+  </p:cSld>
+  <p:clrMapOvr>
+    <a:masterClrMapping/>
+  </p:clrMapOvr>
+</p:sld>
+</file>
+
+<file path=ppt/slides/slide14.xml><?xml version="1.0" encoding="utf-8"?>
+<p:sld xmlns:a="http://schemas.openxmlformats.org/drawingml/2006/main" xmlns:p="http://schemas.openxmlformats.org/presentationml/2006/main" xmlns:r="http://schemas.openxmlformats.org/officeDocument/2006/relationships">
+  <p:cSld>
+    <p:bg>
+      <p:bgPr>
+        <a:solidFill>
+          <a:srgbClr val="0F172A"/>
+        </a:solidFill>
+        <a:effectLst/>
+      </p:bgPr>
+    </p:bg>
+    <p:spTree>
+      <p:nvGrpSpPr>
+        <p:cNvPr id="1" name=""/>
+        <p:cNvGrpSpPr/>
+        <p:nvPr/>
+      </p:nvGrpSpPr>
+      <p:grpSpPr/>
+      <p:sp>
+        <p:nvSpPr>
+          <p:cNvPr id="2" name="TextBox 1"/>
+          <p:cNvSpPr txBox="1"/>
+          <p:nvPr/>
+        </p:nvSpPr>
+        <p:spPr>
+          <a:xfrm>
+            <a:off x="685800" y="2011680"/>
+            <a:ext cx="10817352" cy="1371600"/>
+          </a:xfrm>
+          <a:prstGeom prst="rect">
+            <a:avLst/>
+          </a:prstGeom>
+          <a:noFill/>
+        </p:spPr>
+        <p:txBody>
+          <a:bodyPr wrap="square">
+            <a:spAutoFit/>
+          </a:bodyPr>
+          <a:lstStyle/>
+          <a:p>
+            <a:pPr algn="ctr">
+              <a:defRPr sz="5600" b="1">
+                <a:solidFill>
+                  <a:srgbClr val="10B981"/>
+                </a:solidFill>
+                <a:latin typeface="Segoe UI"/>
+              </a:defRPr>
+            </a:pPr>
+            <a:r>
+              <a:t>Thank You!</a:t>
+            </a:r>
+          </a:p>
+        </p:txBody>
+      </p:sp>
+      <p:sp>
+        <p:nvSpPr>
+          <p:cNvPr id="3" name="TextBox 2"/>
+          <p:cNvSpPr txBox="1"/>
+          <p:nvPr/>
+        </p:nvSpPr>
+        <p:spPr>
+          <a:xfrm>
+            <a:off x="685800" y="3474720"/>
+            <a:ext cx="10817352" cy="1828800"/>
+          </a:xfrm>
+          <a:prstGeom prst="rect">
+            <a:avLst/>
+          </a:prstGeom>
+          <a:noFill/>
+        </p:spPr>
+        <p:txBody>
+          <a:bodyPr wrap="square">
+            <a:spAutoFit/>
+          </a:bodyPr>
+          <a:lstStyle/>
+          <a:p>
+            <a:pPr algn="ctr">
+              <a:defRPr sz="2000" b="1">
+                <a:solidFill>
+                  <a:srgbClr val="F8FAFC"/>
+                </a:solidFill>
+                <a:latin typeface="Segoe UI"/>
+              </a:defRPr>
+            </a:pPr>
+            <a:r>
+              <a:t>Questions &amp; Answers Session</a:t>
+            </a:r>
+          </a:p>
+          <a:p>
+            <a:pPr algn="ctr">
               <a:spcBef>
-                <a:spcPts val="1500"/>
+                <a:spcPts val="2000"/>
               </a:spcBef>
-              <a:defRPr sz="1800" b="1">
-                <a:solidFill>
-                  <a:srgbClr val="10B981"/>
-                </a:solidFill>
-                <a:latin typeface="Segoe UI"/>
-              </a:defRPr>
-            </a:pPr>
-            <a:r>
-              <a:t>Thank You! Questions?</a:t>
+              <a:defRPr sz="1300">
+                <a:solidFill>
+                  <a:srgbClr val="94A3B8"/>
+                </a:solidFill>
+                <a:latin typeface="Segoe UI"/>
+              </a:defRPr>
+            </a:pPr>
+            <a:r>
+              <a:t>GitHub Repository: https://github.com/aperfectrio/weather-data-analyzer-and-prediction</a:t>
+            </a:r>
+            <a:br/>
+            <a:r>
+              <a:t>Contact: [Student Email Placeholder]</a:t>
             </a:r>
           </a:p>
         </p:txBody>
@@ -3996,7 +4955,7 @@
           <a:lstStyle/>
           <a:p>
             <a:pPr>
-              <a:defRPr sz="3200" b="1">
+              <a:defRPr sz="3000" b="1">
                 <a:solidFill>
                   <a:srgbClr val="6366F1"/>
                 </a:solidFill>
@@ -4004,7 +4963,7 @@
               </a:defRPr>
             </a:pPr>
             <a:r>
-              <a:t>Project Overview &amp; Objectives</a:t>
+              <a:t>Why Weather Analysis &amp; Prediction?</a:t>
             </a:r>
           </a:p>
         </p:txBody>
@@ -4017,7 +4976,7 @@
         </p:nvSpPr>
         <p:spPr>
           <a:xfrm>
-            <a:off x="685800" y="1188720"/>
+            <a:off x="685800" y="1143000"/>
             <a:ext cx="10817352" cy="36576"/>
           </a:xfrm>
           <a:prstGeom prst="rect">
@@ -4085,7 +5044,7 @@
               </a:defRPr>
             </a:pPr>
             <a:r>
-              <a:t>Weather Data Analyzer &amp; Temperature Prediction System</a:t>
+              <a:t>Weather Data Analyzer &amp; Temperature Prediction System  |  Intro to OSS Project</a:t>
             </a:r>
           </a:p>
         </p:txBody>
@@ -4098,8 +5057,8 @@
         </p:nvSpPr>
         <p:spPr>
           <a:xfrm>
-            <a:off x="685800" y="1645920"/>
-            <a:ext cx="5120640" cy="4389120"/>
+            <a:off x="685800" y="1554480"/>
+            <a:ext cx="5120640" cy="4572000"/>
           </a:xfrm>
           <a:prstGeom prst="rect">
             <a:avLst/>
@@ -4113,6 +5072,9 @@
           <a:lstStyle/>
           <a:p>
             <a:pPr>
+              <a:spcAft>
+                <a:spcPts val="1200"/>
+              </a:spcAft>
               <a:defRPr sz="2000" b="1">
                 <a:solidFill>
                   <a:srgbClr val="F8FAFC"/>
@@ -4121,7 +5083,7 @@
               </a:defRPr>
             </a:pPr>
             <a:r>
-              <a:t>Core Objectives</a:t>
+              <a:t>The Modern Climate Challenge</a:t>
             </a:r>
           </a:p>
           <a:p>
@@ -4137,7 +5099,7 @@
               </a:defRPr>
             </a:pPr>
             <a:r>
-              <a:t>• Develop an interactive, client-side desktop dashboard using Python &amp; Tkinter.</a:t>
+              <a:t>• Vast, complex weather datasets are generated globally on a daily basis.</a:t>
             </a:r>
           </a:p>
           <a:p>
@@ -4153,7 +5115,7 @@
               </a:defRPr>
             </a:pPr>
             <a:r>
-              <a:t>• Enable parsing, statistical analysis, and graphing of weather records.</a:t>
+              <a:t>• Manual analysis is tedious, slow, and limits search scope.</a:t>
             </a:r>
           </a:p>
           <a:p>
@@ -4169,23 +5131,7 @@
               </a:defRPr>
             </a:pPr>
             <a:r>
-              <a:t>• Implement a machine learning regression model to forecast temperatures.</a:t>
-            </a:r>
-          </a:p>
-          <a:p>
-            <a:pPr>
-              <a:spcAft>
-                <a:spcPts val="1000"/>
-              </a:spcAft>
-              <a:defRPr sz="1400">
-                <a:solidFill>
-                  <a:srgbClr val="94A3B8"/>
-                </a:solidFill>
-                <a:latin typeface="Segoe UI"/>
-              </a:defRPr>
-            </a:pPr>
-            <a:r>
-              <a:t>• Save all visualizations and write detailed analytical report files dynamically.</a:t>
+              <a:t>• Weather dynamics change frequently due to shifting climate conditions.</a:t>
             </a:r>
           </a:p>
         </p:txBody>
@@ -4198,8 +5144,8 @@
         </p:nvSpPr>
         <p:spPr>
           <a:xfrm>
-            <a:off x="6217920" y="1645920"/>
-            <a:ext cx="5120640" cy="4389120"/>
+            <a:off x="6217920" y="1554480"/>
+            <a:ext cx="5120640" cy="4572000"/>
           </a:xfrm>
           <a:prstGeom prst="rect">
             <a:avLst/>
@@ -4213,6 +5159,9 @@
           <a:lstStyle/>
           <a:p>
             <a:pPr>
+              <a:spcAft>
+                <a:spcPts val="1200"/>
+              </a:spcAft>
               <a:defRPr sz="2000" b="1">
                 <a:solidFill>
                   <a:srgbClr val="F8FAFC"/>
@@ -4221,7 +5170,7 @@
               </a:defRPr>
             </a:pPr>
             <a:r>
-              <a:t>Educational Value</a:t>
+              <a:t>Automated Predictive Modeling</a:t>
             </a:r>
           </a:p>
           <a:p>
@@ -4237,7 +5186,7 @@
               </a:defRPr>
             </a:pPr>
             <a:r>
-              <a:t>• Suitable for academic presentations showing modular software design.</a:t>
+              <a:t>• Machine learning discovers hidden patterns in atmospheric variables.</a:t>
             </a:r>
           </a:p>
           <a:p>
@@ -4253,7 +5202,7 @@
               </a:defRPr>
             </a:pPr>
             <a:r>
-              <a:t>• Demonstrates real-world data cleaning, sorting, and regression steps.</a:t>
+              <a:t>• Data visualizations clarify trends for non-technical users.</a:t>
             </a:r>
           </a:p>
           <a:p>
@@ -4269,7 +5218,23 @@
               </a:defRPr>
             </a:pPr>
             <a:r>
-              <a:t>• Adheres strictly to standard open-source structures (MIT licensing, git versioning, modular code).</a:t>
+              <a:t>• Temperature projections support agricultural, urban, and energy planning.</a:t>
+            </a:r>
+          </a:p>
+          <a:p>
+            <a:pPr>
+              <a:spcAft>
+                <a:spcPts val="1000"/>
+              </a:spcAft>
+              <a:defRPr sz="1400">
+                <a:solidFill>
+                  <a:srgbClr val="94A3B8"/>
+                </a:solidFill>
+                <a:latin typeface="Segoe UI"/>
+              </a:defRPr>
+            </a:pPr>
+            <a:r>
+              <a:t>• Our solution: Weather Data Analyzer &amp; Temperature Prediction System.</a:t>
             </a:r>
           </a:p>
         </p:txBody>
@@ -4323,7 +5288,7 @@
           <a:lstStyle/>
           <a:p>
             <a:pPr>
-              <a:defRPr sz="3200" b="1">
+              <a:defRPr sz="3000" b="1">
                 <a:solidFill>
                   <a:srgbClr val="6366F1"/>
                 </a:solidFill>
@@ -4331,7 +5296,7 @@
               </a:defRPr>
             </a:pPr>
             <a:r>
-              <a:t>Core Technology Stack</a:t>
+              <a:t>Project Overview &amp; Tech Stack</a:t>
             </a:r>
           </a:p>
         </p:txBody>
@@ -4344,7 +5309,7 @@
         </p:nvSpPr>
         <p:spPr>
           <a:xfrm>
-            <a:off x="685800" y="1188720"/>
+            <a:off x="685800" y="1143000"/>
             <a:ext cx="10817352" cy="36576"/>
           </a:xfrm>
           <a:prstGeom prst="rect">
@@ -4412,7 +5377,7 @@
               </a:defRPr>
             </a:pPr>
             <a:r>
-              <a:t>Weather Data Analyzer &amp; Temperature Prediction System</a:t>
+              <a:t>Weather Data Analyzer &amp; Temperature Prediction System  |  Intro to OSS Project</a:t>
             </a:r>
           </a:p>
         </p:txBody>
@@ -4425,8 +5390,8 @@
         </p:nvSpPr>
         <p:spPr>
           <a:xfrm>
-            <a:off x="685800" y="1645920"/>
-            <a:ext cx="5120640" cy="4389120"/>
+            <a:off x="685800" y="1554480"/>
+            <a:ext cx="5120640" cy="4572000"/>
           </a:xfrm>
           <a:prstGeom prst="rect">
             <a:avLst/>
@@ -4451,26 +5416,13 @@
               </a:defRPr>
             </a:pPr>
             <a:r>
-              <a:t>Data Processing &amp; Analytics</a:t>
-            </a:r>
-          </a:p>
-          <a:p>
-            <a:pPr>
-              <a:defRPr sz="1500" b="1">
-                <a:solidFill>
-                  <a:srgbClr val="6366F1"/>
-                </a:solidFill>
-                <a:latin typeface="Segoe UI"/>
-              </a:defRPr>
-            </a:pPr>
-            <a:r>
-              <a:t>Pandas</a:t>
-            </a:r>
-          </a:p>
-          <a:p>
-            <a:pPr>
-              <a:spcAft>
-                <a:spcPts val="1000"/>
+              <a:t>Core Functionalities</a:t>
+            </a:r>
+          </a:p>
+          <a:p>
+            <a:pPr>
+              <a:spcAft>
+                <a:spcPts val="800"/>
               </a:spcAft>
               <a:defRPr sz="1300">
                 <a:solidFill>
@@ -4480,26 +5432,13 @@
               </a:defRPr>
             </a:pPr>
             <a:r>
-              <a:t>Used for loaded CSV operations, sorting chronologically, missing cell imputation, and database preview tables.</a:t>
-            </a:r>
-          </a:p>
-          <a:p>
-            <a:pPr>
-              <a:defRPr sz="1500" b="1">
-                <a:solidFill>
-                  <a:srgbClr val="6366F1"/>
-                </a:solidFill>
-                <a:latin typeface="Segoe UI"/>
-              </a:defRPr>
-            </a:pPr>
-            <a:r>
-              <a:t>NumPy</a:t>
-            </a:r>
-          </a:p>
-          <a:p>
-            <a:pPr>
-              <a:spcAft>
-                <a:spcPts val="1000"/>
+              <a:t>• Loads customized CSV files dynamically via native file dialogue.</a:t>
+            </a:r>
+          </a:p>
+          <a:p>
+            <a:pPr>
+              <a:spcAft>
+                <a:spcPts val="800"/>
               </a:spcAft>
               <a:defRPr sz="1300">
                 <a:solidFill>
@@ -4509,26 +5448,13 @@
               </a:defRPr>
             </a:pPr>
             <a:r>
-              <a:t>Handles quick vectorized matrix calculations and math operations.</a:t>
-            </a:r>
-          </a:p>
-          <a:p>
-            <a:pPr>
-              <a:defRPr sz="1500" b="1">
-                <a:solidFill>
-                  <a:srgbClr val="6366F1"/>
-                </a:solidFill>
-                <a:latin typeface="Segoe UI"/>
-              </a:defRPr>
-            </a:pPr>
-            <a:r>
-              <a:t>Scikit-Learn</a:t>
-            </a:r>
-          </a:p>
-          <a:p>
-            <a:pPr>
-              <a:spcAft>
-                <a:spcPts val="1000"/>
+              <a:t>• Processes statistical metrics and logs missing record entries.</a:t>
+            </a:r>
+          </a:p>
+          <a:p>
+            <a:pPr>
+              <a:spcAft>
+                <a:spcPts val="800"/>
               </a:spcAft>
               <a:defRPr sz="1300">
                 <a:solidFill>
@@ -4538,7 +5464,55 @@
               </a:defRPr>
             </a:pPr>
             <a:r>
-              <a:t>Powers the model training and splits. Implements LinearRegression with MAE/R2 evaluators.</a:t>
+              <a:t>• Generates 8 visual plots representing weather variables.</a:t>
+            </a:r>
+          </a:p>
+          <a:p>
+            <a:pPr>
+              <a:spcAft>
+                <a:spcPts val="800"/>
+              </a:spcAft>
+              <a:defRPr sz="1300">
+                <a:solidFill>
+                  <a:srgbClr val="94A3B8"/>
+                </a:solidFill>
+                <a:latin typeface="Segoe UI"/>
+              </a:defRPr>
+            </a:pPr>
+            <a:r>
+              <a:t>• Fits a Linear Regression model to forecast future temperatures.</a:t>
+            </a:r>
+          </a:p>
+          <a:p>
+            <a:pPr>
+              <a:spcAft>
+                <a:spcPts val="800"/>
+              </a:spcAft>
+              <a:defRPr sz="1300">
+                <a:solidFill>
+                  <a:srgbClr val="94A3B8"/>
+                </a:solidFill>
+                <a:latin typeface="Segoe UI"/>
+              </a:defRPr>
+            </a:pPr>
+            <a:r>
+              <a:t>• Compiles summaries into a standardized text file report.</a:t>
+            </a:r>
+          </a:p>
+          <a:p>
+            <a:pPr>
+              <a:spcAft>
+                <a:spcPts val="800"/>
+              </a:spcAft>
+              <a:defRPr sz="1300">
+                <a:solidFill>
+                  <a:srgbClr val="94A3B8"/>
+                </a:solidFill>
+                <a:latin typeface="Segoe UI"/>
+              </a:defRPr>
+            </a:pPr>
+            <a:r>
+              <a:t>• Provides a responsive, styled dark-themed Tkinter GUI.</a:t>
             </a:r>
           </a:p>
         </p:txBody>
@@ -4551,8 +5525,8 @@
         </p:nvSpPr>
         <p:spPr>
           <a:xfrm>
-            <a:off x="6217920" y="1645920"/>
-            <a:ext cx="5120640" cy="4389120"/>
+            <a:off x="6217920" y="1554480"/>
+            <a:ext cx="5120640" cy="4572000"/>
           </a:xfrm>
           <a:prstGeom prst="rect">
             <a:avLst/>
@@ -4577,14 +5551,43 @@
               </a:defRPr>
             </a:pPr>
             <a:r>
-              <a:t>GUI &amp; Visualization Engine</a:t>
-            </a:r>
-          </a:p>
-          <a:p>
-            <a:pPr>
-              <a:defRPr sz="1500" b="1">
-                <a:solidFill>
-                  <a:srgbClr val="10B981"/>
+              <a:t>Software Tech Stack</a:t>
+            </a:r>
+          </a:p>
+          <a:p>
+            <a:pPr>
+              <a:defRPr sz="1400" b="1">
+                <a:solidFill>
+                  <a:srgbClr val="6366F1"/>
+                </a:solidFill>
+                <a:latin typeface="Segoe UI"/>
+              </a:defRPr>
+            </a:pPr>
+            <a:r>
+              <a:t>Python</a:t>
+            </a:r>
+          </a:p>
+          <a:p>
+            <a:pPr>
+              <a:spcAft>
+                <a:spcPts val="600"/>
+              </a:spcAft>
+              <a:defRPr sz="1100">
+                <a:solidFill>
+                  <a:srgbClr val="94A3B8"/>
+                </a:solidFill>
+                <a:latin typeface="Segoe UI"/>
+              </a:defRPr>
+            </a:pPr>
+            <a:r>
+              <a:t>Base language core utilizing standard file, OS, and pickle engines.</a:t>
+            </a:r>
+          </a:p>
+          <a:p>
+            <a:pPr>
+              <a:defRPr sz="1400" b="1">
+                <a:solidFill>
+                  <a:srgbClr val="6366F1"/>
                 </a:solidFill>
                 <a:latin typeface="Segoe UI"/>
               </a:defRPr>
@@ -4596,75 +5599,104 @@
           <a:p>
             <a:pPr>
               <a:spcAft>
-                <a:spcPts val="1000"/>
-              </a:spcAft>
-              <a:defRPr sz="1300">
-                <a:solidFill>
-                  <a:srgbClr val="94A3B8"/>
-                </a:solidFill>
-                <a:latin typeface="Segoe UI"/>
-              </a:defRPr>
-            </a:pPr>
-            <a:r>
-              <a:t>Standard desktop GUI library for cross-platform widgets, sidebar layouts, entries, and interactive components.</a:t>
-            </a:r>
-          </a:p>
-          <a:p>
-            <a:pPr>
-              <a:defRPr sz="1500" b="1">
-                <a:solidFill>
-                  <a:srgbClr val="10B981"/>
-                </a:solidFill>
-                <a:latin typeface="Segoe UI"/>
-              </a:defRPr>
-            </a:pPr>
-            <a:r>
-              <a:t>Matplotlib</a:t>
-            </a:r>
-          </a:p>
-          <a:p>
-            <a:pPr>
-              <a:spcAft>
-                <a:spcPts val="1000"/>
-              </a:spcAft>
-              <a:defRPr sz="1300">
-                <a:solidFill>
-                  <a:srgbClr val="94A3B8"/>
-                </a:solidFill>
-                <a:latin typeface="Segoe UI"/>
-              </a:defRPr>
-            </a:pPr>
-            <a:r>
-              <a:t>Generates high-quality charts and supports TkAgg backend to embed figures directly in Tkinter.</a:t>
-            </a:r>
-          </a:p>
-          <a:p>
-            <a:pPr>
-              <a:defRPr sz="1500" b="1">
-                <a:solidFill>
-                  <a:srgbClr val="10B981"/>
-                </a:solidFill>
-                <a:latin typeface="Segoe UI"/>
-              </a:defRPr>
-            </a:pPr>
-            <a:r>
-              <a:t>Seaborn</a:t>
-            </a:r>
-          </a:p>
-          <a:p>
-            <a:pPr>
-              <a:spcAft>
-                <a:spcPts val="1000"/>
-              </a:spcAft>
-              <a:defRPr sz="1300">
-                <a:solidFill>
-                  <a:srgbClr val="94A3B8"/>
-                </a:solidFill>
-                <a:latin typeface="Segoe UI"/>
-              </a:defRPr>
-            </a:pPr>
-            <a:r>
-              <a:t>Generates statistical plots and heatmaps with elegant palettes.</a:t>
+                <a:spcPts val="600"/>
+              </a:spcAft>
+              <a:defRPr sz="1100">
+                <a:solidFill>
+                  <a:srgbClr val="94A3B8"/>
+                </a:solidFill>
+                <a:latin typeface="Segoe UI"/>
+              </a:defRPr>
+            </a:pPr>
+            <a:r>
+              <a:t>Graphical GUI interface providing custom sidebar panels.</a:t>
+            </a:r>
+          </a:p>
+          <a:p>
+            <a:pPr>
+              <a:defRPr sz="1400" b="1">
+                <a:solidFill>
+                  <a:srgbClr val="6366F1"/>
+                </a:solidFill>
+                <a:latin typeface="Segoe UI"/>
+              </a:defRPr>
+            </a:pPr>
+            <a:r>
+              <a:t>Pandas &amp; NumPy</a:t>
+            </a:r>
+          </a:p>
+          <a:p>
+            <a:pPr>
+              <a:spcAft>
+                <a:spcPts val="600"/>
+              </a:spcAft>
+              <a:defRPr sz="1100">
+                <a:solidFill>
+                  <a:srgbClr val="94A3B8"/>
+                </a:solidFill>
+                <a:latin typeface="Segoe UI"/>
+              </a:defRPr>
+            </a:pPr>
+            <a:r>
+              <a:t>Dataframe operations, chronological sorts, and matrix indices.</a:t>
+            </a:r>
+          </a:p>
+          <a:p>
+            <a:pPr>
+              <a:defRPr sz="1400" b="1">
+                <a:solidFill>
+                  <a:srgbClr val="6366F1"/>
+                </a:solidFill>
+                <a:latin typeface="Segoe UI"/>
+              </a:defRPr>
+            </a:pPr>
+            <a:r>
+              <a:t>Scikit-Learn</a:t>
+            </a:r>
+          </a:p>
+          <a:p>
+            <a:pPr>
+              <a:spcAft>
+                <a:spcPts val="600"/>
+              </a:spcAft>
+              <a:defRPr sz="1100">
+                <a:solidFill>
+                  <a:srgbClr val="94A3B8"/>
+                </a:solidFill>
+                <a:latin typeface="Segoe UI"/>
+              </a:defRPr>
+            </a:pPr>
+            <a:r>
+              <a:t>Standard OLS Linear Regression and evaluation metrics.</a:t>
+            </a:r>
+          </a:p>
+          <a:p>
+            <a:pPr>
+              <a:defRPr sz="1400" b="1">
+                <a:solidFill>
+                  <a:srgbClr val="6366F1"/>
+                </a:solidFill>
+                <a:latin typeface="Segoe UI"/>
+              </a:defRPr>
+            </a:pPr>
+            <a:r>
+              <a:t>Matplotlib &amp; Seaborn</a:t>
+            </a:r>
+          </a:p>
+          <a:p>
+            <a:pPr>
+              <a:spcAft>
+                <a:spcPts val="600"/>
+              </a:spcAft>
+              <a:defRPr sz="1100">
+                <a:solidFill>
+                  <a:srgbClr val="94A3B8"/>
+                </a:solidFill>
+                <a:latin typeface="Segoe UI"/>
+              </a:defRPr>
+            </a:pPr>
+            <a:r>
+              <a:t>Plot rendering embedded directly into the GUI region.</a:t>
             </a:r>
           </a:p>
         </p:txBody>
@@ -4718,7 +5750,7 @@
           <a:lstStyle/>
           <a:p>
             <a:pPr>
-              <a:defRPr sz="3200" b="1">
+              <a:defRPr sz="3000" b="1">
                 <a:solidFill>
                   <a:srgbClr val="6366F1"/>
                 </a:solidFill>
@@ -4726,7 +5758,7 @@
               </a:defRPr>
             </a:pPr>
             <a:r>
-              <a:t>System Architecture &amp; Workflow</a:t>
+              <a:t>Dataset Details &amp; Suitability</a:t>
             </a:r>
           </a:p>
         </p:txBody>
@@ -4739,7 +5771,7 @@
         </p:nvSpPr>
         <p:spPr>
           <a:xfrm>
-            <a:off x="685800" y="1188720"/>
+            <a:off x="685800" y="1143000"/>
             <a:ext cx="10817352" cy="36576"/>
           </a:xfrm>
           <a:prstGeom prst="rect">
@@ -4807,7 +5839,7 @@
               </a:defRPr>
             </a:pPr>
             <a:r>
-              <a:t>Weather Data Analyzer &amp; Temperature Prediction System</a:t>
+              <a:t>Weather Data Analyzer &amp; Temperature Prediction System  |  Intro to OSS Project</a:t>
             </a:r>
           </a:p>
         </p:txBody>
@@ -4820,8 +5852,8 @@
         </p:nvSpPr>
         <p:spPr>
           <a:xfrm>
-            <a:off x="685800" y="1645920"/>
-            <a:ext cx="5120640" cy="4389120"/>
+            <a:off x="685800" y="1554480"/>
+            <a:ext cx="5120640" cy="4572000"/>
           </a:xfrm>
           <a:prstGeom prst="rect">
             <a:avLst/>
@@ -4846,65 +5878,71 @@
               </a:defRPr>
             </a:pPr>
             <a:r>
-              <a:t>System Components</a:t>
-            </a:r>
-          </a:p>
-          <a:p>
-            <a:pPr>
-              <a:defRPr sz="1500" b="1">
-                <a:solidFill>
-                  <a:srgbClr val="A78BFA"/>
-                </a:solidFill>
-                <a:latin typeface="Segoe UI"/>
-              </a:defRPr>
-            </a:pPr>
-            <a:r>
-              <a:t>WeatherDataProcessor Class</a:t>
-            </a:r>
-          </a:p>
-          <a:p>
-            <a:pPr>
-              <a:spcAft>
-                <a:spcPts val="1200"/>
-              </a:spcAft>
-              <a:defRPr sz="1300">
-                <a:solidFill>
-                  <a:srgbClr val="94A3B8"/>
-                </a:solidFill>
-                <a:latin typeface="Segoe UI"/>
-              </a:defRPr>
-            </a:pPr>
-            <a:r>
-              <a:t>Independent engine containing data cleaning, descriptive statistics, chart saving, model training, validation splits, and file report compilation.</a:t>
-            </a:r>
-          </a:p>
-          <a:p>
-            <a:pPr>
-              <a:defRPr sz="1500" b="1">
-                <a:solidFill>
-                  <a:srgbClr val="A78BFA"/>
-                </a:solidFill>
-                <a:latin typeface="Segoe UI"/>
-              </a:defRPr>
-            </a:pPr>
-            <a:r>
-              <a:t>WeatherApp Class</a:t>
-            </a:r>
-          </a:p>
-          <a:p>
-            <a:pPr>
-              <a:spcAft>
-                <a:spcPts val="1200"/>
-              </a:spcAft>
-              <a:defRPr sz="1300">
-                <a:solidFill>
-                  <a:srgbClr val="94A3B8"/>
-                </a:solidFill>
-                <a:latin typeface="Segoe UI"/>
-              </a:defRPr>
-            </a:pPr>
-            <a:r>
-              <a:t>The presentation layer controlling window geometry, responsive layout framing, scrollable panels, Tkinter bindings, treeview previews, and dynamic forms.</a:t>
+              <a:t>Weather Features</a:t>
+            </a:r>
+          </a:p>
+          <a:p>
+            <a:pPr>
+              <a:spcAft>
+                <a:spcPts val="1000"/>
+              </a:spcAft>
+              <a:defRPr sz="1400">
+                <a:solidFill>
+                  <a:srgbClr val="94A3B8"/>
+                </a:solidFill>
+                <a:latin typeface="Segoe UI"/>
+              </a:defRPr>
+            </a:pPr>
+            <a:r>
+              <a:t>• Tested using real-world Seoul weather observations (2022–2024).</a:t>
+            </a:r>
+          </a:p>
+          <a:p>
+            <a:pPr>
+              <a:spcAft>
+                <a:spcPts val="1000"/>
+              </a:spcAft>
+              <a:defRPr sz="1400">
+                <a:solidFill>
+                  <a:srgbClr val="94A3B8"/>
+                </a:solidFill>
+                <a:latin typeface="Segoe UI"/>
+              </a:defRPr>
+            </a:pPr>
+            <a:r>
+              <a:t>• Target Variable: Average Temperature (temp column).</a:t>
+            </a:r>
+          </a:p>
+          <a:p>
+            <a:pPr>
+              <a:spcAft>
+                <a:spcPts val="1000"/>
+              </a:spcAft>
+              <a:defRPr sz="1400">
+                <a:solidFill>
+                  <a:srgbClr val="94A3B8"/>
+                </a:solidFill>
+                <a:latin typeface="Segoe UI"/>
+              </a:defRPr>
+            </a:pPr>
+            <a:r>
+              <a:t>• Predictors: Humidity, Windspeed, Precipitation, Pressure, Cloudcover.</a:t>
+            </a:r>
+          </a:p>
+          <a:p>
+            <a:pPr>
+              <a:spcAft>
+                <a:spcPts val="1000"/>
+              </a:spcAft>
+              <a:defRPr sz="1400">
+                <a:solidFill>
+                  <a:srgbClr val="94A3B8"/>
+                </a:solidFill>
+                <a:latin typeface="Segoe UI"/>
+              </a:defRPr>
+            </a:pPr>
+            <a:r>
+              <a:t>• Other columns: datetime, tempmax, tempmin, conditions text.</a:t>
             </a:r>
           </a:p>
         </p:txBody>
@@ -4917,8 +5955,8 @@
         </p:nvSpPr>
         <p:spPr>
           <a:xfrm>
-            <a:off x="6217920" y="1645920"/>
-            <a:ext cx="5120640" cy="4389120"/>
+            <a:off x="6217920" y="1554480"/>
+            <a:ext cx="5120640" cy="4572000"/>
           </a:xfrm>
           <a:prstGeom prst="rect">
             <a:avLst/>
@@ -4943,13 +5981,13 @@
               </a:defRPr>
             </a:pPr>
             <a:r>
-              <a:t>Application Pipeline Flow</a:t>
-            </a:r>
-          </a:p>
-          <a:p>
-            <a:pPr>
-              <a:spcAft>
-                <a:spcPts val="600"/>
+              <a:t>Dataset Suitability</a:t>
+            </a:r>
+          </a:p>
+          <a:p>
+            <a:pPr>
+              <a:spcAft>
+                <a:spcPts val="1000"/>
               </a:spcAft>
               <a:defRPr sz="1400">
                 <a:solidFill>
@@ -4959,13 +5997,13 @@
               </a:defRPr>
             </a:pPr>
             <a:r>
-              <a:t>1. Browse &amp; Load CSV Dataset</a:t>
-            </a:r>
-          </a:p>
-          <a:p>
-            <a:pPr>
-              <a:spcAft>
-                <a:spcPts val="600"/>
+              <a:t>• Continuous variables contain clear linear trends over annual periods.</a:t>
+            </a:r>
+          </a:p>
+          <a:p>
+            <a:pPr>
+              <a:spcAft>
+                <a:spcPts val="1000"/>
               </a:spcAft>
               <a:defRPr sz="1400">
                 <a:solidFill>
@@ -4975,13 +6013,13 @@
               </a:defRPr>
             </a:pPr>
             <a:r>
-              <a:t>2. Parse Date Chronology &amp; Clean Missing Elements</a:t>
-            </a:r>
-          </a:p>
-          <a:p>
-            <a:pPr>
-              <a:spcAft>
-                <a:spcPts val="600"/>
+              <a:t>• Contains enough samples (700+ rows) to train a robust local predictor.</a:t>
+            </a:r>
+          </a:p>
+          <a:p>
+            <a:pPr>
+              <a:spcAft>
+                <a:spcPts val="1000"/>
               </a:spcAft>
               <a:defRPr sz="1400">
                 <a:solidFill>
@@ -4991,13 +6029,13 @@
               </a:defRPr>
             </a:pPr>
             <a:r>
-              <a:t>3. Compile Stats Dashboard &amp; Draw 7 Saveable Charts</a:t>
-            </a:r>
-          </a:p>
-          <a:p>
-            <a:pPr>
-              <a:spcAft>
-                <a:spcPts val="600"/>
+              <a:t>• Missing values are distributed normally, allowing clean mean imputation.</a:t>
+            </a:r>
+          </a:p>
+          <a:p>
+            <a:pPr>
+              <a:spcAft>
+                <a:spcPts val="1000"/>
               </a:spcAft>
               <a:defRPr sz="1400">
                 <a:solidFill>
@@ -5007,55 +6045,7 @@
               </a:defRPr>
             </a:pPr>
             <a:r>
-              <a:t>4. Filter Predictors &amp; Split Dataset into 80/20</a:t>
-            </a:r>
-          </a:p>
-          <a:p>
-            <a:pPr>
-              <a:spcAft>
-                <a:spcPts val="600"/>
-              </a:spcAft>
-              <a:defRPr sz="1400">
-                <a:solidFill>
-                  <a:srgbClr val="94A3B8"/>
-                </a:solidFill>
-                <a:latin typeface="Segoe UI"/>
-              </a:defRPr>
-            </a:pPr>
-            <a:r>
-              <a:t>5. Train Model &amp; Score Validation Curve Errors</a:t>
-            </a:r>
-          </a:p>
-          <a:p>
-            <a:pPr>
-              <a:spcAft>
-                <a:spcPts val="600"/>
-              </a:spcAft>
-              <a:defRPr sz="1400">
-                <a:solidFill>
-                  <a:srgbClr val="94A3B8"/>
-                </a:solidFill>
-                <a:latin typeface="Segoe UI"/>
-              </a:defRPr>
-            </a:pPr>
-            <a:r>
-              <a:t>6. Render Dynamic Inputs Form &amp; Score Prediction</a:t>
-            </a:r>
-          </a:p>
-          <a:p>
-            <a:pPr>
-              <a:spcAft>
-                <a:spcPts val="600"/>
-              </a:spcAft>
-              <a:defRPr sz="1400">
-                <a:solidFill>
-                  <a:srgbClr val="94A3B8"/>
-                </a:solidFill>
-                <a:latin typeface="Segoe UI"/>
-              </a:defRPr>
-            </a:pPr>
-            <a:r>
-              <a:t>7. Compile and Export Analytical Text File Report</a:t>
+              <a:t>• Predictor features correspond directly to physical weather dynamics.</a:t>
             </a:r>
           </a:p>
         </p:txBody>
@@ -5109,7 +6099,7 @@
           <a:lstStyle/>
           <a:p>
             <a:pPr>
-              <a:defRPr sz="3200" b="1">
+              <a:defRPr sz="3000" b="1">
                 <a:solidFill>
                   <a:srgbClr val="6366F1"/>
                 </a:solidFill>
@@ -5117,7 +6107,7 @@
               </a:defRPr>
             </a:pPr>
             <a:r>
-              <a:t>Smart Data Parsing &amp; Imputation</a:t>
+              <a:t>System Architecture &amp; Workflow</a:t>
             </a:r>
           </a:p>
         </p:txBody>
@@ -5130,7 +6120,7 @@
         </p:nvSpPr>
         <p:spPr>
           <a:xfrm>
-            <a:off x="685800" y="1188720"/>
+            <a:off x="685800" y="1143000"/>
             <a:ext cx="10817352" cy="36576"/>
           </a:xfrm>
           <a:prstGeom prst="rect">
@@ -5198,7 +6188,7 @@
               </a:defRPr>
             </a:pPr>
             <a:r>
-              <a:t>Weather Data Analyzer &amp; Temperature Prediction System</a:t>
+              <a:t>Weather Data Analyzer &amp; Temperature Prediction System  |  Intro to OSS Project</a:t>
             </a:r>
           </a:p>
         </p:txBody>
@@ -5211,8 +6201,8 @@
         </p:nvSpPr>
         <p:spPr>
           <a:xfrm>
-            <a:off x="685800" y="1645920"/>
-            <a:ext cx="5120640" cy="4389120"/>
+            <a:off x="685800" y="1554480"/>
+            <a:ext cx="5120640" cy="4572000"/>
           </a:xfrm>
           <a:prstGeom prst="rect">
             <a:avLst/>
@@ -5237,55 +6227,123 @@
               </a:defRPr>
             </a:pPr>
             <a:r>
-              <a:t>Regex Column Mapping</a:t>
-            </a:r>
-          </a:p>
-          <a:p>
-            <a:pPr>
-              <a:spcAft>
-                <a:spcPts val="1000"/>
-              </a:spcAft>
-              <a:defRPr sz="1400">
-                <a:solidFill>
-                  <a:srgbClr val="94A3B8"/>
-                </a:solidFill>
-                <a:latin typeface="Segoe UI"/>
-              </a:defRPr>
-            </a:pPr>
-            <a:r>
-              <a:t>• Avoids static column name dependencies, making it robust for other weather datasets.</a:t>
-            </a:r>
-          </a:p>
-          <a:p>
-            <a:pPr>
-              <a:spcAft>
-                <a:spcPts val="1000"/>
-              </a:spcAft>
-              <a:defRPr sz="1400">
-                <a:solidFill>
-                  <a:srgbClr val="94A3B8"/>
-                </a:solidFill>
-                <a:latin typeface="Segoe UI"/>
-              </a:defRPr>
-            </a:pPr>
-            <a:r>
-              <a:t>• Scans headers using case-insensitive regex pattern checks.</a:t>
-            </a:r>
-          </a:p>
-          <a:p>
-            <a:pPr>
-              <a:spcAft>
-                <a:spcPts val="1000"/>
-              </a:spcAft>
-              <a:defRPr sz="1400">
-                <a:solidFill>
-                  <a:srgbClr val="94A3B8"/>
-                </a:solidFill>
-                <a:latin typeface="Segoe UI"/>
-              </a:defRPr>
-            </a:pPr>
-            <a:r>
-              <a:t>• Auto-detects Date, Temp (Target), Humidity, Precip/Rainfall, Windspeed, and Condition categories.</a:t>
+              <a:t>Workflow Pipeline Steps</a:t>
+            </a:r>
+          </a:p>
+          <a:p>
+            <a:pPr>
+              <a:defRPr sz="1400" b="1">
+                <a:solidFill>
+                  <a:srgbClr val="A78BFA"/>
+                </a:solidFill>
+                <a:latin typeface="Segoe UI"/>
+              </a:defRPr>
+            </a:pPr>
+            <a:r>
+              <a:t>1. Dataset Loading</a:t>
+            </a:r>
+          </a:p>
+          <a:p>
+            <a:pPr>
+              <a:spcAft>
+                <a:spcPts val="600"/>
+              </a:spcAft>
+              <a:defRPr sz="1200">
+                <a:solidFill>
+                  <a:srgbClr val="94A3B8"/>
+                </a:solidFill>
+                <a:latin typeface="Segoe UI"/>
+              </a:defRPr>
+            </a:pPr>
+            <a:r>
+              <a:t>Browse local filesystem for weather CSV files using Tkinter Dialog.</a:t>
+            </a:r>
+          </a:p>
+          <a:p>
+            <a:pPr>
+              <a:defRPr sz="1400" b="1">
+                <a:solidFill>
+                  <a:srgbClr val="A78BFA"/>
+                </a:solidFill>
+                <a:latin typeface="Segoe UI"/>
+              </a:defRPr>
+            </a:pPr>
+            <a:r>
+              <a:t>2. Data Preprocessing</a:t>
+            </a:r>
+          </a:p>
+          <a:p>
+            <a:pPr>
+              <a:spcAft>
+                <a:spcPts val="600"/>
+              </a:spcAft>
+              <a:defRPr sz="1200">
+                <a:solidFill>
+                  <a:srgbClr val="94A3B8"/>
+                </a:solidFill>
+                <a:latin typeface="Segoe UI"/>
+              </a:defRPr>
+            </a:pPr>
+            <a:r>
+              <a:t>Chronological sorting, date parsing, and missing cell average fills.</a:t>
+            </a:r>
+          </a:p>
+          <a:p>
+            <a:pPr>
+              <a:defRPr sz="1400" b="1">
+                <a:solidFill>
+                  <a:srgbClr val="A78BFA"/>
+                </a:solidFill>
+                <a:latin typeface="Segoe UI"/>
+              </a:defRPr>
+            </a:pPr>
+            <a:r>
+              <a:t>3. Weather Analysis</a:t>
+            </a:r>
+          </a:p>
+          <a:p>
+            <a:pPr>
+              <a:spcAft>
+                <a:spcPts val="600"/>
+              </a:spcAft>
+              <a:defRPr sz="1200">
+                <a:solidFill>
+                  <a:srgbClr val="94A3B8"/>
+                </a:solidFill>
+                <a:latin typeface="Segoe UI"/>
+              </a:defRPr>
+            </a:pPr>
+            <a:r>
+              <a:t>Extract descriptive maximums, minimums, and averages across metrics.</a:t>
+            </a:r>
+          </a:p>
+          <a:p>
+            <a:pPr>
+              <a:defRPr sz="1400" b="1">
+                <a:solidFill>
+                  <a:srgbClr val="A78BFA"/>
+                </a:solidFill>
+                <a:latin typeface="Segoe UI"/>
+              </a:defRPr>
+            </a:pPr>
+            <a:r>
+              <a:t>4. Visualizations</a:t>
+            </a:r>
+          </a:p>
+          <a:p>
+            <a:pPr>
+              <a:spcAft>
+                <a:spcPts val="600"/>
+              </a:spcAft>
+              <a:defRPr sz="1200">
+                <a:solidFill>
+                  <a:srgbClr val="94A3B8"/>
+                </a:solidFill>
+                <a:latin typeface="Segoe UI"/>
+              </a:defRPr>
+            </a:pPr>
+            <a:r>
+              <a:t>Generate and save 8 charts inside output/ folder.</a:t>
             </a:r>
           </a:p>
         </p:txBody>
@@ -5298,8 +6356,8 @@
         </p:nvSpPr>
         <p:spPr>
           <a:xfrm>
-            <a:off x="6217920" y="1645920"/>
-            <a:ext cx="5120640" cy="4389120"/>
+            <a:off x="6217920" y="1554480"/>
+            <a:ext cx="5120640" cy="4572000"/>
           </a:xfrm>
           <a:prstGeom prst="rect">
             <a:avLst/>
@@ -5324,71 +6382,94 @@
               </a:defRPr>
             </a:pPr>
             <a:r>
-              <a:t>Robust Clean &amp; Imputation</a:t>
-            </a:r>
-          </a:p>
-          <a:p>
-            <a:pPr>
-              <a:spcAft>
-                <a:spcPts val="1000"/>
-              </a:spcAft>
-              <a:defRPr sz="1400">
-                <a:solidFill>
-                  <a:srgbClr val="94A3B8"/>
-                </a:solidFill>
-                <a:latin typeface="Segoe UI"/>
-              </a:defRPr>
-            </a:pPr>
-            <a:r>
-              <a:t>• Parses date variables into standard Datetime index structures and sorts chronologically.</a:t>
-            </a:r>
-          </a:p>
-          <a:p>
-            <a:pPr>
-              <a:spcAft>
-                <a:spcPts val="1000"/>
-              </a:spcAft>
-              <a:defRPr sz="1400">
-                <a:solidFill>
-                  <a:srgbClr val="94A3B8"/>
-                </a:solidFill>
-                <a:latin typeface="Segoe UI"/>
-              </a:defRPr>
-            </a:pPr>
-            <a:r>
-              <a:t>• Auto-imputes empty cells in numerical feature columns using the column averages.</a:t>
-            </a:r>
-          </a:p>
-          <a:p>
-            <a:pPr>
-              <a:spcAft>
-                <a:spcPts val="1000"/>
-              </a:spcAft>
-              <a:defRPr sz="1400">
-                <a:solidFill>
-                  <a:srgbClr val="94A3B8"/>
-                </a:solidFill>
-                <a:latin typeface="Segoe UI"/>
-              </a:defRPr>
-            </a:pPr>
-            <a:r>
-              <a:t>• Auto-imputes empty cells in categorical columns using the column modes.</a:t>
-            </a:r>
-          </a:p>
-          <a:p>
-            <a:pPr>
-              <a:spcAft>
-                <a:spcPts val="1000"/>
-              </a:spcAft>
-              <a:defRPr sz="1400">
-                <a:solidFill>
-                  <a:srgbClr val="94A3B8"/>
-                </a:solidFill>
-                <a:latin typeface="Segoe UI"/>
-              </a:defRPr>
-            </a:pPr>
-            <a:r>
-              <a:t>• Includes safe defaults: if non-essential columns (like windspeed) are missing, stats display 'N/A' without crashing.</a:t>
+              <a:t>Workflow Pipeline Steps (Cont.)</a:t>
+            </a:r>
+          </a:p>
+          <a:p>
+            <a:pPr>
+              <a:defRPr sz="1400" b="1">
+                <a:solidFill>
+                  <a:srgbClr val="10B981"/>
+                </a:solidFill>
+                <a:latin typeface="Segoe UI"/>
+              </a:defRPr>
+            </a:pPr>
+            <a:r>
+              <a:t>5. Machine Learning</a:t>
+            </a:r>
+          </a:p>
+          <a:p>
+            <a:pPr>
+              <a:spcAft>
+                <a:spcPts val="600"/>
+              </a:spcAft>
+              <a:defRPr sz="1200">
+                <a:solidFill>
+                  <a:srgbClr val="94A3B8"/>
+                </a:solidFill>
+                <a:latin typeface="Segoe UI"/>
+              </a:defRPr>
+            </a:pPr>
+            <a:r>
+              <a:t>Split dataset 80/20. Fit OLS coefficients and intercept weights.</a:t>
+            </a:r>
+          </a:p>
+          <a:p>
+            <a:pPr>
+              <a:defRPr sz="1400" b="1">
+                <a:solidFill>
+                  <a:srgbClr val="10B981"/>
+                </a:solidFill>
+                <a:latin typeface="Segoe UI"/>
+              </a:defRPr>
+            </a:pPr>
+            <a:r>
+              <a:t>6. Temp Prediction</a:t>
+            </a:r>
+          </a:p>
+          <a:p>
+            <a:pPr>
+              <a:spcAft>
+                <a:spcPts val="600"/>
+              </a:spcAft>
+              <a:defRPr sz="1200">
+                <a:solidFill>
+                  <a:srgbClr val="94A3B8"/>
+                </a:solidFill>
+                <a:latin typeface="Segoe UI"/>
+              </a:defRPr>
+            </a:pPr>
+            <a:r>
+              <a:t>User enters inputs in GUI widgets; model displays prediction output.</a:t>
+            </a:r>
+          </a:p>
+          <a:p>
+            <a:pPr>
+              <a:defRPr sz="1400" b="1">
+                <a:solidFill>
+                  <a:srgbClr val="10B981"/>
+                </a:solidFill>
+                <a:latin typeface="Segoe UI"/>
+              </a:defRPr>
+            </a:pPr>
+            <a:r>
+              <a:t>7. GUI Display</a:t>
+            </a:r>
+          </a:p>
+          <a:p>
+            <a:pPr>
+              <a:spcAft>
+                <a:spcPts val="600"/>
+              </a:spcAft>
+              <a:defRPr sz="1200">
+                <a:solidFill>
+                  <a:srgbClr val="94A3B8"/>
+                </a:solidFill>
+                <a:latin typeface="Segoe UI"/>
+              </a:defRPr>
+            </a:pPr>
+            <a:r>
+              <a:t>Packs and embeds widgets, data tables, and Matplotlib plots inline.</a:t>
             </a:r>
           </a:p>
         </p:txBody>
@@ -5442,7 +6523,7 @@
           <a:lstStyle/>
           <a:p>
             <a:pPr>
-              <a:defRPr sz="3200" b="1">
+              <a:defRPr sz="3000" b="1">
                 <a:solidFill>
                   <a:srgbClr val="6366F1"/>
                 </a:solidFill>
@@ -5450,7 +6531,7 @@
               </a:defRPr>
             </a:pPr>
             <a:r>
-              <a:t>Exploratory Visualizations Gallery</a:t>
+              <a:t>Data Preprocessing Operations</a:t>
             </a:r>
           </a:p>
         </p:txBody>
@@ -5463,7 +6544,7 @@
         </p:nvSpPr>
         <p:spPr>
           <a:xfrm>
-            <a:off x="685800" y="1188720"/>
+            <a:off x="685800" y="1143000"/>
             <a:ext cx="10817352" cy="36576"/>
           </a:xfrm>
           <a:prstGeom prst="rect">
@@ -5531,7 +6612,7 @@
               </a:defRPr>
             </a:pPr>
             <a:r>
-              <a:t>Weather Data Analyzer &amp; Temperature Prediction System</a:t>
+              <a:t>Weather Data Analyzer &amp; Temperature Prediction System  |  Intro to OSS Project</a:t>
             </a:r>
           </a:p>
         </p:txBody>
@@ -5544,8 +6625,8 @@
         </p:nvSpPr>
         <p:spPr>
           <a:xfrm>
-            <a:off x="685800" y="1645920"/>
-            <a:ext cx="5120640" cy="4389120"/>
+            <a:off x="685800" y="1554480"/>
+            <a:ext cx="5120640" cy="4572000"/>
           </a:xfrm>
           <a:prstGeom prst="rect">
             <a:avLst/>
@@ -5570,7 +6651,7 @@
               </a:defRPr>
             </a:pPr>
             <a:r>
-              <a:t>7 Automated Saved Charts</a:t>
+              <a:t>Ingestion &amp; Cleaning</a:t>
             </a:r>
           </a:p>
           <a:p>
@@ -5583,13 +6664,13 @@
               </a:defRPr>
             </a:pPr>
             <a:r>
-              <a:t>1. Temperature Trend</a:t>
-            </a:r>
-          </a:p>
-          <a:p>
-            <a:pPr>
-              <a:spcAft>
-                <a:spcPts val="400"/>
+              <a:t>Step 1: Load Weather Dataset</a:t>
+            </a:r>
+          </a:p>
+          <a:p>
+            <a:pPr>
+              <a:spcAft>
+                <a:spcPts val="1000"/>
               </a:spcAft>
               <a:defRPr sz="1200">
                 <a:solidFill>
@@ -5599,7 +6680,7 @@
               </a:defRPr>
             </a:pPr>
             <a:r>
-              <a:t>Line chart displaying daily heat levels over time.</a:t>
+              <a:t>File dialogue loading of raw CSV tables. Regex matcher scans header strings to locate mapping columns, eliminating hardcoded column requirements.</a:t>
             </a:r>
           </a:p>
           <a:p>
@@ -5612,13 +6693,13 @@
               </a:defRPr>
             </a:pPr>
             <a:r>
-              <a:t>2. Monthly Avg Temperature</a:t>
-            </a:r>
-          </a:p>
-          <a:p>
-            <a:pPr>
-              <a:spcAft>
-                <a:spcPts val="400"/>
+              <a:t>Step 2: Data Cleaning &amp; Imputation</a:t>
+            </a:r>
+          </a:p>
+          <a:p>
+            <a:pPr>
+              <a:spcAft>
+                <a:spcPts val="1000"/>
               </a:spcAft>
               <a:defRPr sz="1200">
                 <a:solidFill>
@@ -5628,65 +6709,7 @@
               </a:defRPr>
             </a:pPr>
             <a:r>
-              <a:t>Bar chart showing avg temperatures across months.</a:t>
-            </a:r>
-          </a:p>
-          <a:p>
-            <a:pPr>
-              <a:defRPr sz="1400" b="1">
-                <a:solidFill>
-                  <a:srgbClr val="6366F1"/>
-                </a:solidFill>
-                <a:latin typeface="Segoe UI"/>
-              </a:defRPr>
-            </a:pPr>
-            <a:r>
-              <a:t>3. Monthly Rainfall</a:t>
-            </a:r>
-          </a:p>
-          <a:p>
-            <a:pPr>
-              <a:spcAft>
-                <a:spcPts val="400"/>
-              </a:spcAft>
-              <a:defRPr sz="1200">
-                <a:solidFill>
-                  <a:srgbClr val="94A3B8"/>
-                </a:solidFill>
-                <a:latin typeface="Segoe UI"/>
-              </a:defRPr>
-            </a:pPr>
-            <a:r>
-              <a:t>Bar chart illustrating cumulative precipitation.</a:t>
-            </a:r>
-          </a:p>
-          <a:p>
-            <a:pPr>
-              <a:defRPr sz="1400" b="1">
-                <a:solidFill>
-                  <a:srgbClr val="6366F1"/>
-                </a:solidFill>
-                <a:latin typeface="Segoe UI"/>
-              </a:defRPr>
-            </a:pPr>
-            <a:r>
-              <a:t>4. Weather Conditions</a:t>
-            </a:r>
-          </a:p>
-          <a:p>
-            <a:pPr>
-              <a:spcAft>
-                <a:spcPts val="400"/>
-              </a:spcAft>
-              <a:defRPr sz="1200">
-                <a:solidFill>
-                  <a:srgbClr val="94A3B8"/>
-                </a:solidFill>
-                <a:latin typeface="Segoe UI"/>
-              </a:defRPr>
-            </a:pPr>
-            <a:r>
-              <a:t>Pie chart breaking down overall sky condition ratios.</a:t>
+              <a:t>Converts dates to structured Datetime indexes. Missing numerical values are filled with column means; missing categories are filled with column modes.</a:t>
             </a:r>
           </a:p>
         </p:txBody>
@@ -5699,8 +6722,8 @@
         </p:nvSpPr>
         <p:spPr>
           <a:xfrm>
-            <a:off x="6217920" y="1645920"/>
-            <a:ext cx="5120640" cy="4389120"/>
+            <a:off x="6217920" y="1554480"/>
+            <a:ext cx="5120640" cy="4572000"/>
           </a:xfrm>
           <a:prstGeom prst="rect">
             <a:avLst/>
@@ -5725,7 +6748,7 @@
               </a:defRPr>
             </a:pPr>
             <a:r>
-              <a:t>Advanced Graphics Features</a:t>
+              <a:t>Features &amp; Splits</a:t>
             </a:r>
           </a:p>
           <a:p>
@@ -5738,13 +6761,13 @@
               </a:defRPr>
             </a:pPr>
             <a:r>
-              <a:t>5. Humidity Distribution</a:t>
-            </a:r>
-          </a:p>
-          <a:p>
-            <a:pPr>
-              <a:spcAft>
-                <a:spcPts val="400"/>
+              <a:t>Step 3: Feature Selection</a:t>
+            </a:r>
+          </a:p>
+          <a:p>
+            <a:pPr>
+              <a:spcAft>
+                <a:spcPts val="1000"/>
               </a:spcAft>
               <a:defRPr sz="1200">
                 <a:solidFill>
@@ -5754,7 +6777,7 @@
               </a:defRPr>
             </a:pPr>
             <a:r>
-              <a:t>Histogram displaying density ranges and frequencies of humidity.</a:t>
+              <a:t>Strips date stamps and string fields. Excludes high correlation variables (target average, max, min, feelslike, dew points) to prevent target leakage.</a:t>
             </a:r>
           </a:p>
           <a:p>
@@ -5767,13 +6790,13 @@
               </a:defRPr>
             </a:pPr>
             <a:r>
-              <a:t>6. Temp vs. Humidity</a:t>
-            </a:r>
-          </a:p>
-          <a:p>
-            <a:pPr>
-              <a:spcAft>
-                <a:spcPts val="400"/>
+              <a:t>Step 4: Train/Test Split</a:t>
+            </a:r>
+          </a:p>
+          <a:p>
+            <a:pPr>
+              <a:spcAft>
+                <a:spcPts val="1000"/>
               </a:spcAft>
               <a:defRPr sz="1200">
                 <a:solidFill>
@@ -5783,36 +6806,7 @@
               </a:defRPr>
             </a:pPr>
             <a:r>
-              <a:t>Scatter plot tracking moisture variations against temperatures.</a:t>
-            </a:r>
-          </a:p>
-          <a:p>
-            <a:pPr>
-              <a:defRPr sz="1400" b="1">
-                <a:solidFill>
-                  <a:srgbClr val="10B981"/>
-                </a:solidFill>
-                <a:latin typeface="Segoe UI"/>
-              </a:defRPr>
-            </a:pPr>
-            <a:r>
-              <a:t>7. Feature Correlation Heatmap</a:t>
-            </a:r>
-          </a:p>
-          <a:p>
-            <a:pPr>
-              <a:spcAft>
-                <a:spcPts val="400"/>
-              </a:spcAft>
-              <a:defRPr sz="1200">
-                <a:solidFill>
-                  <a:srgbClr val="94A3B8"/>
-                </a:solidFill>
-                <a:latin typeface="Segoe UI"/>
-              </a:defRPr>
-            </a:pPr>
-            <a:r>
-              <a:t>Seaborn matrix mapping correlation coefficients between all numerical features.</a:t>
+              <a:t>Splits the cleaned dataset into 80% Training records (used to fit parameters) and 20% Testing records (used for out-of-sample evaluation validation).</a:t>
             </a:r>
           </a:p>
         </p:txBody>
@@ -5866,7 +6860,7 @@
           <a:lstStyle/>
           <a:p>
             <a:pPr>
-              <a:defRPr sz="3200" b="1">
+              <a:defRPr sz="3000" b="1">
                 <a:solidFill>
                   <a:srgbClr val="6366F1"/>
                 </a:solidFill>
@@ -5874,7 +6868,7 @@
               </a:defRPr>
             </a:pPr>
             <a:r>
-              <a:t>Predictive Machine Learning Engine</a:t>
+              <a:t>Machine Learning: Linear Regression</a:t>
             </a:r>
           </a:p>
         </p:txBody>
@@ -5887,7 +6881,7 @@
         </p:nvSpPr>
         <p:spPr>
           <a:xfrm>
-            <a:off x="685800" y="1188720"/>
+            <a:off x="685800" y="1143000"/>
             <a:ext cx="10817352" cy="36576"/>
           </a:xfrm>
           <a:prstGeom prst="rect">
@@ -5955,7 +6949,7 @@
               </a:defRPr>
             </a:pPr>
             <a:r>
-              <a:t>Weather Data Analyzer &amp; Temperature Prediction System</a:t>
+              <a:t>Weather Data Analyzer &amp; Temperature Prediction System  |  Intro to OSS Project</a:t>
             </a:r>
           </a:p>
         </p:txBody>
@@ -5968,8 +6962,8 @@
         </p:nvSpPr>
         <p:spPr>
           <a:xfrm>
-            <a:off x="685800" y="1645920"/>
-            <a:ext cx="5120640" cy="4389120"/>
+            <a:off x="685800" y="1554480"/>
+            <a:ext cx="5120640" cy="4572000"/>
           </a:xfrm>
           <a:prstGeom prst="rect">
             <a:avLst/>
@@ -5994,71 +6988,71 @@
               </a:defRPr>
             </a:pPr>
             <a:r>
-              <a:t>Linear Regression Core</a:t>
-            </a:r>
-          </a:p>
-          <a:p>
-            <a:pPr>
-              <a:spcAft>
-                <a:spcPts val="1000"/>
-              </a:spcAft>
-              <a:defRPr sz="1400">
-                <a:solidFill>
-                  <a:srgbClr val="94A3B8"/>
-                </a:solidFill>
-                <a:latin typeface="Segoe UI"/>
-              </a:defRPr>
-            </a:pPr>
-            <a:r>
-              <a:t>• Uses ordinary least squares linear regression from Scikit-Learn.</a:t>
-            </a:r>
-          </a:p>
-          <a:p>
-            <a:pPr>
-              <a:spcAft>
-                <a:spcPts val="1000"/>
-              </a:spcAft>
-              <a:defRPr sz="1400">
-                <a:solidFill>
-                  <a:srgbClr val="94A3B8"/>
-                </a:solidFill>
-                <a:latin typeface="Segoe UI"/>
-              </a:defRPr>
-            </a:pPr>
-            <a:r>
-              <a:t>• Target: Predict Temperature (temp column).</a:t>
-            </a:r>
-          </a:p>
-          <a:p>
-            <a:pPr>
-              <a:spcAft>
-                <a:spcPts val="1000"/>
-              </a:spcAft>
-              <a:defRPr sz="1400">
-                <a:solidFill>
-                  <a:srgbClr val="94A3B8"/>
-                </a:solidFill>
-                <a:latin typeface="Segoe UI"/>
-              </a:defRPr>
-            </a:pPr>
-            <a:r>
-              <a:t>• Features Selection: Automatically extracts all numeric columns while filtering out target temp, max/min, apparent feels-like, dew points, and indices.</a:t>
-            </a:r>
-          </a:p>
-          <a:p>
-            <a:pPr>
-              <a:spcAft>
-                <a:spcPts val="1000"/>
-              </a:spcAft>
-              <a:defRPr sz="1400">
-                <a:solidFill>
-                  <a:srgbClr val="94A3B8"/>
-                </a:solidFill>
-                <a:latin typeface="Segoe UI"/>
-              </a:defRPr>
-            </a:pPr>
-            <a:r>
-              <a:t>• Prevents overfitting or target leakage (no 'cheating' features).</a:t>
+              <a:t>Why Linear Regression?</a:t>
+            </a:r>
+          </a:p>
+          <a:p>
+            <a:pPr>
+              <a:spcAft>
+                <a:spcPts val="800"/>
+              </a:spcAft>
+              <a:defRPr sz="1300">
+                <a:solidFill>
+                  <a:srgbClr val="94A3B8"/>
+                </a:solidFill>
+                <a:latin typeface="Segoe UI"/>
+              </a:defRPr>
+            </a:pPr>
+            <a:r>
+              <a:t>• Highly interpretable: displays exact mathematical relationship weights between inputs and outputs.</a:t>
+            </a:r>
+          </a:p>
+          <a:p>
+            <a:pPr>
+              <a:spcAft>
+                <a:spcPts val="800"/>
+              </a:spcAft>
+              <a:defRPr sz="1300">
+                <a:solidFill>
+                  <a:srgbClr val="94A3B8"/>
+                </a:solidFill>
+                <a:latin typeface="Segoe UI"/>
+              </a:defRPr>
+            </a:pPr>
+            <a:r>
+              <a:t>• Computationally lightweight: compiles instantly without GPU hardware requirements.</a:t>
+            </a:r>
+          </a:p>
+          <a:p>
+            <a:pPr>
+              <a:spcAft>
+                <a:spcPts val="800"/>
+              </a:spcAft>
+              <a:defRPr sz="1300">
+                <a:solidFill>
+                  <a:srgbClr val="94A3B8"/>
+                </a:solidFill>
+                <a:latin typeface="Segoe UI"/>
+              </a:defRPr>
+            </a:pPr>
+            <a:r>
+              <a:t>• Excellent baseline representation for continuous numerical patterns like temperature waves.</a:t>
+            </a:r>
+          </a:p>
+          <a:p>
+            <a:pPr>
+              <a:spcAft>
+                <a:spcPts val="800"/>
+              </a:spcAft>
+              <a:defRPr sz="1300">
+                <a:solidFill>
+                  <a:srgbClr val="94A3B8"/>
+                </a:solidFill>
+                <a:latin typeface="Segoe UI"/>
+              </a:defRPr>
+            </a:pPr>
+            <a:r>
+              <a:t>• Allows direct extraction of coefficients for project code testing.</a:t>
             </a:r>
           </a:p>
         </p:txBody>
@@ -6071,8 +7065,8 @@
         </p:nvSpPr>
         <p:spPr>
           <a:xfrm>
-            <a:off x="6217920" y="1645920"/>
-            <a:ext cx="5120640" cy="4389120"/>
+            <a:off x="6217920" y="1554480"/>
+            <a:ext cx="5120640" cy="4572000"/>
           </a:xfrm>
           <a:prstGeom prst="rect">
             <a:avLst/>
@@ -6097,55 +7091,152 @@
               </a:defRPr>
             </a:pPr>
             <a:r>
-              <a:t>Execution Steps</a:t>
-            </a:r>
-          </a:p>
-          <a:p>
-            <a:pPr>
-              <a:spcAft>
-                <a:spcPts val="1200"/>
-              </a:spcAft>
-              <a:defRPr sz="1300">
-                <a:solidFill>
-                  <a:srgbClr val="94A3B8"/>
-                </a:solidFill>
-                <a:latin typeface="Segoe UI"/>
-              </a:defRPr>
-            </a:pPr>
-            <a:r>
-              <a:t>1. Train/Test Split: Splits records into 80% training set and 20% testing set to ensure out-of-sample evaluation.</a:t>
-            </a:r>
-          </a:p>
-          <a:p>
-            <a:pPr>
-              <a:spcAft>
-                <a:spcPts val="1200"/>
-              </a:spcAft>
-              <a:defRPr sz="1300">
-                <a:solidFill>
-                  <a:srgbClr val="94A3B8"/>
-                </a:solidFill>
-                <a:latin typeface="Segoe UI"/>
-              </a:defRPr>
-            </a:pPr>
-            <a:r>
-              <a:t>2. Intercept &amp; Weights: Computes the base offset constant and regression coefficients for each predictor variable.</a:t>
-            </a:r>
-          </a:p>
-          <a:p>
-            <a:pPr>
-              <a:spcAft>
-                <a:spcPts val="1200"/>
-              </a:spcAft>
-              <a:defRPr sz="1300">
-                <a:solidFill>
-                  <a:srgbClr val="94A3B8"/>
-                </a:solidFill>
-                <a:latin typeface="Segoe UI"/>
-              </a:defRPr>
-            </a:pPr>
-            <a:r>
-              <a:t>3. Local Serialization: Serializes model metadata, parameters, and features dynamically to 'output/temperature_model.pkl'.</a:t>
+              <a:t>Model Specification</a:t>
+            </a:r>
+          </a:p>
+          <a:p>
+            <a:pPr>
+              <a:defRPr sz="1300" b="1">
+                <a:solidFill>
+                  <a:srgbClr val="10B981"/>
+                </a:solidFill>
+                <a:latin typeface="Segoe UI"/>
+              </a:defRPr>
+            </a:pPr>
+            <a:r>
+              <a:t>Target Variable</a:t>
+            </a:r>
+          </a:p>
+          <a:p>
+            <a:pPr>
+              <a:spcAft>
+                <a:spcPts val="400"/>
+              </a:spcAft>
+              <a:defRPr sz="1100">
+                <a:solidFill>
+                  <a:srgbClr val="94A3B8"/>
+                </a:solidFill>
+                <a:latin typeface="Segoe UI"/>
+              </a:defRPr>
+            </a:pPr>
+            <a:r>
+              <a:t>Daily Average Temperature (temp) in °C.</a:t>
+            </a:r>
+          </a:p>
+          <a:p>
+            <a:pPr>
+              <a:defRPr sz="1300" b="1">
+                <a:solidFill>
+                  <a:srgbClr val="10B981"/>
+                </a:solidFill>
+                <a:latin typeface="Segoe UI"/>
+              </a:defRPr>
+            </a:pPr>
+            <a:r>
+              <a:t>Input Features</a:t>
+            </a:r>
+          </a:p>
+          <a:p>
+            <a:pPr>
+              <a:spcAft>
+                <a:spcPts val="400"/>
+              </a:spcAft>
+              <a:defRPr sz="1100">
+                <a:solidFill>
+                  <a:srgbClr val="94A3B8"/>
+                </a:solidFill>
+                <a:latin typeface="Segoe UI"/>
+              </a:defRPr>
+            </a:pPr>
+            <a:r>
+              <a:t>Humidity, Precipitation, Wind Speed, Pressure, Cloud Cover, and others.</a:t>
+            </a:r>
+          </a:p>
+          <a:p>
+            <a:pPr>
+              <a:defRPr sz="1300" b="1">
+                <a:solidFill>
+                  <a:srgbClr val="10B981"/>
+                </a:solidFill>
+                <a:latin typeface="Segoe UI"/>
+              </a:defRPr>
+            </a:pPr>
+            <a:r>
+              <a:t>Training Engine</a:t>
+            </a:r>
+          </a:p>
+          <a:p>
+            <a:pPr>
+              <a:spcAft>
+                <a:spcPts val="400"/>
+              </a:spcAft>
+              <a:defRPr sz="1100">
+                <a:solidFill>
+                  <a:srgbClr val="94A3B8"/>
+                </a:solidFill>
+                <a:latin typeface="Segoe UI"/>
+              </a:defRPr>
+            </a:pPr>
+            <a:r>
+              <a:t>Fits coefficients by minimizing sum of squared residuals on training data (OLS).</a:t>
+            </a:r>
+          </a:p>
+          <a:p>
+            <a:pPr>
+              <a:defRPr sz="1300" b="1">
+                <a:solidFill>
+                  <a:srgbClr val="10B981"/>
+                </a:solidFill>
+                <a:latin typeface="Segoe UI"/>
+              </a:defRPr>
+            </a:pPr>
+            <a:r>
+              <a:t>Model Output</a:t>
+            </a:r>
+          </a:p>
+          <a:p>
+            <a:pPr>
+              <a:spcAft>
+                <a:spcPts val="400"/>
+              </a:spcAft>
+              <a:defRPr sz="1100">
+                <a:solidFill>
+                  <a:srgbClr val="94A3B8"/>
+                </a:solidFill>
+                <a:latin typeface="Segoe UI"/>
+              </a:defRPr>
+            </a:pPr>
+            <a:r>
+              <a:t>Continuous temperature prediction value in Celsius (°C).</a:t>
+            </a:r>
+          </a:p>
+          <a:p>
+            <a:pPr>
+              <a:defRPr sz="1300" b="1">
+                <a:solidFill>
+                  <a:srgbClr val="10B981"/>
+                </a:solidFill>
+                <a:latin typeface="Segoe UI"/>
+              </a:defRPr>
+            </a:pPr>
+            <a:r>
+              <a:t>Local Storage</a:t>
+            </a:r>
+          </a:p>
+          <a:p>
+            <a:pPr>
+              <a:spcAft>
+                <a:spcPts val="400"/>
+              </a:spcAft>
+              <a:defRPr sz="1100">
+                <a:solidFill>
+                  <a:srgbClr val="94A3B8"/>
+                </a:solidFill>
+                <a:latin typeface="Segoe UI"/>
+              </a:defRPr>
+            </a:pPr>
+            <a:r>
+              <a:t>Saves model weights locally as 'output/temperature_model.pkl'.</a:t>
             </a:r>
           </a:p>
         </p:txBody>
@@ -6199,7 +7290,7 @@
           <a:lstStyle/>
           <a:p>
             <a:pPr>
-              <a:defRPr sz="3200" b="1">
+              <a:defRPr sz="3000" b="1">
                 <a:solidFill>
                   <a:srgbClr val="6366F1"/>
                 </a:solidFill>
@@ -6207,7 +7298,7 @@
               </a:defRPr>
             </a:pPr>
             <a:r>
-              <a:t>Model Performance &amp; Validation</a:t>
+              <a:t>Results &amp; Visualizations Catalog</a:t>
             </a:r>
           </a:p>
         </p:txBody>
@@ -6220,7 +7311,7 @@
         </p:nvSpPr>
         <p:spPr>
           <a:xfrm>
-            <a:off x="685800" y="1188720"/>
+            <a:off x="685800" y="1143000"/>
             <a:ext cx="10817352" cy="36576"/>
           </a:xfrm>
           <a:prstGeom prst="rect">
@@ -6288,7 +7379,7 @@
               </a:defRPr>
             </a:pPr>
             <a:r>
-              <a:t>Weather Data Analyzer &amp; Temperature Prediction System</a:t>
+              <a:t>Weather Data Analyzer &amp; Temperature Prediction System  |  Intro to OSS Project</a:t>
             </a:r>
           </a:p>
         </p:txBody>
@@ -6301,8 +7392,8 @@
         </p:nvSpPr>
         <p:spPr>
           <a:xfrm>
-            <a:off x="685800" y="1645920"/>
-            <a:ext cx="5120640" cy="4389120"/>
+            <a:off x="685800" y="1554480"/>
+            <a:ext cx="5120640" cy="4572000"/>
           </a:xfrm>
           <a:prstGeom prst="rect">
             <a:avLst/>
@@ -6327,7 +7418,7 @@
               </a:defRPr>
             </a:pPr>
             <a:r>
-              <a:t>Metrics (Seoul Dataset)</a:t>
+              <a:t>Exploratory Charts (1 - 4)</a:t>
             </a:r>
           </a:p>
           <a:p>
@@ -6340,7 +7431,7 @@
               </a:defRPr>
             </a:pPr>
             <a:r>
-              <a:t>R² Score (R-squared):  0.7698</a:t>
+              <a:t>1. Temperature Trend</a:t>
             </a:r>
           </a:p>
           <a:p>
@@ -6348,15 +7439,15 @@
               <a:spcAft>
                 <a:spcPts val="600"/>
               </a:spcAft>
-              <a:defRPr sz="1200">
-                <a:solidFill>
-                  <a:srgbClr val="94A3B8"/>
-                </a:solidFill>
-                <a:latin typeface="Segoe UI"/>
-              </a:defRPr>
-            </a:pPr>
-            <a:r>
-              <a:t>Explains ~77.0% of the temperature variance in test sets.</a:t>
+              <a:defRPr sz="1100">
+                <a:solidFill>
+                  <a:srgbClr val="94A3B8"/>
+                </a:solidFill>
+                <a:latin typeface="Segoe UI"/>
+              </a:defRPr>
+            </a:pPr>
+            <a:r>
+              <a:t>Line chart showing temperature variations over the date index range.</a:t>
             </a:r>
           </a:p>
           <a:p>
@@ -6369,7 +7460,7 @@
               </a:defRPr>
             </a:pPr>
             <a:r>
-              <a:t>Mean Absolute Error:   4.1071 °C</a:t>
+              <a:t>2. Monthly Average Temp</a:t>
             </a:r>
           </a:p>
           <a:p>
@@ -6377,15 +7468,15 @@
               <a:spcAft>
                 <a:spcPts val="600"/>
               </a:spcAft>
-              <a:defRPr sz="1200">
-                <a:solidFill>
-                  <a:srgbClr val="94A3B8"/>
-                </a:solidFill>
-                <a:latin typeface="Segoe UI"/>
-              </a:defRPr>
-            </a:pPr>
-            <a:r>
-              <a:t>On average, temp predictions differ by just ~4.1 degrees.</a:t>
+              <a:defRPr sz="1100">
+                <a:solidFill>
+                  <a:srgbClr val="94A3B8"/>
+                </a:solidFill>
+                <a:latin typeface="Segoe UI"/>
+              </a:defRPr>
+            </a:pPr>
+            <a:r>
+              <a:t>Bar chart showing monthly average temperature changes over a year.</a:t>
             </a:r>
           </a:p>
           <a:p>
@@ -6398,7 +7489,7 @@
               </a:defRPr>
             </a:pPr>
             <a:r>
-              <a:t>Mean Squared Error:    27.5747</a:t>
+              <a:t>3. Monthly Rainfall</a:t>
             </a:r>
           </a:p>
           <a:p>
@@ -6406,15 +7497,15 @@
               <a:spcAft>
                 <a:spcPts val="600"/>
               </a:spcAft>
-              <a:defRPr sz="1200">
-                <a:solidFill>
-                  <a:srgbClr val="94A3B8"/>
-                </a:solidFill>
-                <a:latin typeface="Segoe UI"/>
-              </a:defRPr>
-            </a:pPr>
-            <a:r>
-              <a:t>Penalty measure scoring lower deviation spreads.</a:t>
+              <a:defRPr sz="1100">
+                <a:solidFill>
+                  <a:srgbClr val="94A3B8"/>
+                </a:solidFill>
+                <a:latin typeface="Segoe UI"/>
+              </a:defRPr>
+            </a:pPr>
+            <a:r>
+              <a:t>Bar chart summarizing total precipitation grouped by month.</a:t>
             </a:r>
           </a:p>
           <a:p>
@@ -6427,7 +7518,7 @@
               </a:defRPr>
             </a:pPr>
             <a:r>
-              <a:t>Root Mean Sq. Error:   5.2512 °C</a:t>
+              <a:t>4. Weather Conditions</a:t>
             </a:r>
           </a:p>
           <a:p>
@@ -6435,15 +7526,15 @@
               <a:spcAft>
                 <a:spcPts val="600"/>
               </a:spcAft>
-              <a:defRPr sz="1200">
-                <a:solidFill>
-                  <a:srgbClr val="94A3B8"/>
-                </a:solidFill>
-                <a:latin typeface="Segoe UI"/>
-              </a:defRPr>
-            </a:pPr>
-            <a:r>
-              <a:t>Standard deviation score of forecast residuals.</a:t>
+              <a:defRPr sz="1100">
+                <a:solidFill>
+                  <a:srgbClr val="94A3B8"/>
+                </a:solidFill>
+                <a:latin typeface="Segoe UI"/>
+              </a:defRPr>
+            </a:pPr>
+            <a:r>
+              <a:t>Pie chart showing percentage share of categorical conditions.</a:t>
             </a:r>
           </a:p>
         </p:txBody>
@@ -6456,8 +7547,8 @@
         </p:nvSpPr>
         <p:spPr>
           <a:xfrm>
-            <a:off x="6217920" y="1645920"/>
-            <a:ext cx="5120640" cy="4389120"/>
+            <a:off x="6217920" y="1554480"/>
+            <a:ext cx="5120640" cy="4572000"/>
           </a:xfrm>
           <a:prstGeom prst="rect">
             <a:avLst/>
@@ -6482,55 +7573,123 @@
               </a:defRPr>
             </a:pPr>
             <a:r>
-              <a:t>Actual vs. Predicted Validation</a:t>
-            </a:r>
-          </a:p>
-          <a:p>
-            <a:pPr>
-              <a:spcAft>
-                <a:spcPts val="1000"/>
-              </a:spcAft>
-              <a:defRPr sz="1400">
-                <a:solidFill>
-                  <a:srgbClr val="94A3B8"/>
-                </a:solidFill>
-                <a:latin typeface="Segoe UI"/>
-              </a:defRPr>
-            </a:pPr>
-            <a:r>
-              <a:t>• A validation chart is saved to 'output/actual_vs_predicted.png'.</a:t>
-            </a:r>
-          </a:p>
-          <a:p>
-            <a:pPr>
-              <a:spcAft>
-                <a:spcPts val="1000"/>
-              </a:spcAft>
-              <a:defRPr sz="1400">
-                <a:solidFill>
-                  <a:srgbClr val="94A3B8"/>
-                </a:solidFill>
-                <a:latin typeface="Segoe UI"/>
-              </a:defRPr>
-            </a:pPr>
-            <a:r>
-              <a:t>• Draws actual temperatures overlaid with predicted lines for test samples.</a:t>
-            </a:r>
-          </a:p>
-          <a:p>
-            <a:pPr>
-              <a:spcAft>
-                <a:spcPts val="1000"/>
-              </a:spcAft>
-              <a:defRPr sz="1400">
-                <a:solidFill>
-                  <a:srgbClr val="94A3B8"/>
-                </a:solidFill>
-                <a:latin typeface="Segoe UI"/>
-              </a:defRPr>
-            </a:pPr>
-            <a:r>
-              <a:t>• Allows direct visual analysis of regression fit lines during project demonstrations.</a:t>
+              <a:t>Statistical Charts (5 - 8)</a:t>
+            </a:r>
+          </a:p>
+          <a:p>
+            <a:pPr>
+              <a:defRPr sz="1400" b="1">
+                <a:solidFill>
+                  <a:srgbClr val="10B981"/>
+                </a:solidFill>
+                <a:latin typeface="Segoe UI"/>
+              </a:defRPr>
+            </a:pPr>
+            <a:r>
+              <a:t>5. Humidity Histogram</a:t>
+            </a:r>
+          </a:p>
+          <a:p>
+            <a:pPr>
+              <a:spcAft>
+                <a:spcPts val="600"/>
+              </a:spcAft>
+              <a:defRPr sz="1100">
+                <a:solidFill>
+                  <a:srgbClr val="94A3B8"/>
+                </a:solidFill>
+                <a:latin typeface="Segoe UI"/>
+              </a:defRPr>
+            </a:pPr>
+            <a:r>
+              <a:t>Plots humidity frequency bins to display data distribution shape.</a:t>
+            </a:r>
+          </a:p>
+          <a:p>
+            <a:pPr>
+              <a:defRPr sz="1400" b="1">
+                <a:solidFill>
+                  <a:srgbClr val="10B981"/>
+                </a:solidFill>
+                <a:latin typeface="Segoe UI"/>
+              </a:defRPr>
+            </a:pPr>
+            <a:r>
+              <a:t>6. Temp vs. Humidity</a:t>
+            </a:r>
+          </a:p>
+          <a:p>
+            <a:pPr>
+              <a:spcAft>
+                <a:spcPts val="600"/>
+              </a:spcAft>
+              <a:defRPr sz="1100">
+                <a:solidFill>
+                  <a:srgbClr val="94A3B8"/>
+                </a:solidFill>
+                <a:latin typeface="Segoe UI"/>
+              </a:defRPr>
+            </a:pPr>
+            <a:r>
+              <a:t>Scatter plot tracking temperature values against humidity percentages.</a:t>
+            </a:r>
+          </a:p>
+          <a:p>
+            <a:pPr>
+              <a:defRPr sz="1400" b="1">
+                <a:solidFill>
+                  <a:srgbClr val="10B981"/>
+                </a:solidFill>
+                <a:latin typeface="Segoe UI"/>
+              </a:defRPr>
+            </a:pPr>
+            <a:r>
+              <a:t>7. Correlation Heatmap</a:t>
+            </a:r>
+          </a:p>
+          <a:p>
+            <a:pPr>
+              <a:spcAft>
+                <a:spcPts val="600"/>
+              </a:spcAft>
+              <a:defRPr sz="1100">
+                <a:solidFill>
+                  <a:srgbClr val="94A3B8"/>
+                </a:solidFill>
+                <a:latin typeface="Segoe UI"/>
+              </a:defRPr>
+            </a:pPr>
+            <a:r>
+              <a:t>Seaborn matrix map showing correlation values between numerical features.</a:t>
+            </a:r>
+          </a:p>
+          <a:p>
+            <a:pPr>
+              <a:defRPr sz="1400" b="1">
+                <a:solidFill>
+                  <a:srgbClr val="10B981"/>
+                </a:solidFill>
+                <a:latin typeface="Segoe UI"/>
+              </a:defRPr>
+            </a:pPr>
+            <a:r>
+              <a:t>8. Actual vs. Predicted</a:t>
+            </a:r>
+          </a:p>
+          <a:p>
+            <a:pPr>
+              <a:spcAft>
+                <a:spcPts val="600"/>
+              </a:spcAft>
+              <a:defRPr sz="1100">
+                <a:solidFill>
+                  <a:srgbClr val="94A3B8"/>
+                </a:solidFill>
+                <a:latin typeface="Segoe UI"/>
+              </a:defRPr>
+            </a:pPr>
+            <a:r>
+              <a:t>Line plot overlay validating target vs predicted test values.</a:t>
             </a:r>
           </a:p>
         </p:txBody>
@@ -6584,7 +7743,7 @@
           <a:lstStyle/>
           <a:p>
             <a:pPr>
-              <a:defRPr sz="3200" b="1">
+              <a:defRPr sz="3000" b="1">
                 <a:solidFill>
                   <a:srgbClr val="6366F1"/>
                 </a:solidFill>
@@ -6592,7 +7751,7 @@
               </a:defRPr>
             </a:pPr>
             <a:r>
-              <a:t>Interactive Desktop GUI Design</a:t>
+              <a:t>Model Evaluation Metrics</a:t>
             </a:r>
           </a:p>
         </p:txBody>
@@ -6605,7 +7764,7 @@
         </p:nvSpPr>
         <p:spPr>
           <a:xfrm>
-            <a:off x="685800" y="1188720"/>
+            <a:off x="685800" y="1143000"/>
             <a:ext cx="10817352" cy="36576"/>
           </a:xfrm>
           <a:prstGeom prst="rect">
@@ -6673,7 +7832,7 @@
               </a:defRPr>
             </a:pPr>
             <a:r>
-              <a:t>Weather Data Analyzer &amp; Temperature Prediction System</a:t>
+              <a:t>Weather Data Analyzer &amp; Temperature Prediction System  |  Intro to OSS Project</a:t>
             </a:r>
           </a:p>
         </p:txBody>
@@ -6686,8 +7845,8 @@
         </p:nvSpPr>
         <p:spPr>
           <a:xfrm>
-            <a:off x="685800" y="1645920"/>
-            <a:ext cx="5120640" cy="4389120"/>
+            <a:off x="685800" y="1554480"/>
+            <a:ext cx="5120640" cy="4572000"/>
           </a:xfrm>
           <a:prstGeom prst="rect">
             <a:avLst/>
@@ -6712,71 +7871,94 @@
               </a:defRPr>
             </a:pPr>
             <a:r>
-              <a:t>Visual Layout Styling</a:t>
-            </a:r>
-          </a:p>
-          <a:p>
-            <a:pPr>
-              <a:spcAft>
-                <a:spcPts val="1000"/>
-              </a:spcAft>
-              <a:defRPr sz="1400">
-                <a:solidFill>
-                  <a:srgbClr val="94A3B8"/>
-                </a:solidFill>
-                <a:latin typeface="Segoe UI"/>
-              </a:defRPr>
-            </a:pPr>
-            <a:r>
-              <a:t>• Premium slate dark theme (Slate-900 background, Slate-800 card frames).</a:t>
-            </a:r>
-          </a:p>
-          <a:p>
-            <a:pPr>
-              <a:spcAft>
-                <a:spcPts val="1000"/>
-              </a:spcAft>
-              <a:defRPr sz="1400">
-                <a:solidFill>
-                  <a:srgbClr val="94A3B8"/>
-                </a:solidFill>
-                <a:latin typeface="Segoe UI"/>
-              </a:defRPr>
-            </a:pPr>
-            <a:r>
-              <a:t>• Widescreen 1200x800 dimensions, structured to prevent visual crowding.</a:t>
-            </a:r>
-          </a:p>
-          <a:p>
-            <a:pPr>
-              <a:spcAft>
-                <a:spcPts val="1000"/>
-              </a:spcAft>
-              <a:defRPr sz="1400">
-                <a:solidFill>
-                  <a:srgbClr val="94A3B8"/>
-                </a:solidFill>
-                <a:latin typeface="Segoe UI"/>
-              </a:defRPr>
-            </a:pPr>
-            <a:r>
-              <a:t>• Navigation sidebar with active color-toggling and hover animation micro-effects.</a:t>
-            </a:r>
-          </a:p>
-          <a:p>
-            <a:pPr>
-              <a:spcAft>
-                <a:spcPts val="1000"/>
-              </a:spcAft>
-              <a:defRPr sz="1400">
-                <a:solidFill>
-                  <a:srgbClr val="94A3B8"/>
-                </a:solidFill>
-                <a:latin typeface="Segoe UI"/>
-              </a:defRPr>
-            </a:pPr>
-            <a:r>
-              <a:t>• Responsive canvas-scrollbar wrapper with mousewheel bindings.</a:t>
+              <a:t>Mathematical Metrics</a:t>
+            </a:r>
+          </a:p>
+          <a:p>
+            <a:pPr>
+              <a:defRPr sz="1400" b="1">
+                <a:solidFill>
+                  <a:srgbClr val="6366F1"/>
+                </a:solidFill>
+                <a:latin typeface="Segoe UI"/>
+              </a:defRPr>
+            </a:pPr>
+            <a:r>
+              <a:t>Mean Absolute Error (MAE): 4.1071 °C</a:t>
+            </a:r>
+          </a:p>
+          <a:p>
+            <a:pPr>
+              <a:spcAft>
+                <a:spcPts val="800"/>
+              </a:spcAft>
+              <a:defRPr sz="1100">
+                <a:solidFill>
+                  <a:srgbClr val="94A3B8"/>
+                </a:solidFill>
+                <a:latin typeface="Segoe UI"/>
+              </a:defRPr>
+            </a:pPr>
+            <a:r>
+              <a:t>Measures the average magnitude of absolute residuals (distance between target and predictions).</a:t>
+            </a:r>
+          </a:p>
+          <a:p>
+            <a:pPr>
+              <a:defRPr sz="1400" b="1">
+                <a:solidFill>
+                  <a:srgbClr val="6366F1"/>
+                </a:solidFill>
+                <a:latin typeface="Segoe UI"/>
+              </a:defRPr>
+            </a:pPr>
+            <a:r>
+              <a:t>Mean Squared Error (MSE): 27.5747</a:t>
+            </a:r>
+          </a:p>
+          <a:p>
+            <a:pPr>
+              <a:spcAft>
+                <a:spcPts val="800"/>
+              </a:spcAft>
+              <a:defRPr sz="1100">
+                <a:solidFill>
+                  <a:srgbClr val="94A3B8"/>
+                </a:solidFill>
+                <a:latin typeface="Segoe UI"/>
+              </a:defRPr>
+            </a:pPr>
+            <a:r>
+              <a:t>Measures average squared residual distances. Useful to heavily penalize large errors.</a:t>
+            </a:r>
+          </a:p>
+          <a:p>
+            <a:pPr>
+              <a:defRPr sz="1400" b="1">
+                <a:solidFill>
+                  <a:srgbClr val="6366F1"/>
+                </a:solidFill>
+                <a:latin typeface="Segoe UI"/>
+              </a:defRPr>
+            </a:pPr>
+            <a:r>
+              <a:t>Root Mean Squared Error (RMSE): 5.2512 °C</a:t>
+            </a:r>
+          </a:p>
+          <a:p>
+            <a:pPr>
+              <a:spcAft>
+                <a:spcPts val="800"/>
+              </a:spcAft>
+              <a:defRPr sz="1100">
+                <a:solidFill>
+                  <a:srgbClr val="94A3B8"/>
+                </a:solidFill>
+                <a:latin typeface="Segoe UI"/>
+              </a:defRPr>
+            </a:pPr>
+            <a:r>
+              <a:t>Square root of MSE, scaling error values directly back to temperature units.</a:t>
             </a:r>
           </a:p>
         </p:txBody>
@@ -6789,8 +7971,8 @@
         </p:nvSpPr>
         <p:spPr>
           <a:xfrm>
-            <a:off x="6217920" y="1645920"/>
-            <a:ext cx="5120640" cy="4389120"/>
+            <a:off x="6217920" y="1554480"/>
+            <a:ext cx="5120640" cy="4572000"/>
           </a:xfrm>
           <a:prstGeom prst="rect">
             <a:avLst/>
@@ -6815,71 +7997,94 @@
               </a:defRPr>
             </a:pPr>
             <a:r>
-              <a:t>Dynamic Predictive Entry Form</a:t>
-            </a:r>
-          </a:p>
-          <a:p>
-            <a:pPr>
-              <a:spcAft>
-                <a:spcPts val="1000"/>
-              </a:spcAft>
-              <a:defRPr sz="1400">
-                <a:solidFill>
-                  <a:srgbClr val="94A3B8"/>
-                </a:solidFill>
-                <a:latin typeface="Segoe UI"/>
-              </a:defRPr>
-            </a:pPr>
-            <a:r>
-              <a:t>• Scans the model features and dynamically constructs text entry boxes.</a:t>
-            </a:r>
-          </a:p>
-          <a:p>
-            <a:pPr>
-              <a:spcAft>
-                <a:spcPts val="1000"/>
-              </a:spcAft>
-              <a:defRPr sz="1400">
-                <a:solidFill>
-                  <a:srgbClr val="94A3B8"/>
-                </a:solidFill>
-                <a:latin typeface="Segoe UI"/>
-              </a:defRPr>
-            </a:pPr>
-            <a:r>
-              <a:t>• Automatically adjusts input boxes if a different dataset is loaded.</a:t>
-            </a:r>
-          </a:p>
-          <a:p>
-            <a:pPr>
-              <a:spcAft>
-                <a:spcPts val="1000"/>
-              </a:spcAft>
-              <a:defRPr sz="1400">
-                <a:solidFill>
-                  <a:srgbClr val="94A3B8"/>
-                </a:solidFill>
-                <a:latin typeface="Segoe UI"/>
-              </a:defRPr>
-            </a:pPr>
-            <a:r>
-              <a:t>• Fills out average values from the dataset as helpful default values.</a:t>
-            </a:r>
-          </a:p>
-          <a:p>
-            <a:pPr>
-              <a:spcAft>
-                <a:spcPts val="1000"/>
-              </a:spcAft>
-              <a:defRPr sz="1400">
-                <a:solidFill>
-                  <a:srgbClr val="94A3B8"/>
-                </a:solidFill>
-                <a:latin typeface="Segoe UI"/>
-              </a:defRPr>
-            </a:pPr>
-            <a:r>
-              <a:t>• Evaluates inputs and outputs results in a large badge, color-coded based on temperature range (cold, moderate, hot).</a:t>
+              <a:t>R-Squared &amp; Validation</a:t>
+            </a:r>
+          </a:p>
+          <a:p>
+            <a:pPr>
+              <a:defRPr sz="1300" b="1">
+                <a:solidFill>
+                  <a:srgbClr val="10B981"/>
+                </a:solidFill>
+                <a:latin typeface="Segoe UI"/>
+              </a:defRPr>
+            </a:pPr>
+            <a:r>
+              <a:t>R² Score (Coefficient of Determination): 0.7698</a:t>
+            </a:r>
+          </a:p>
+          <a:p>
+            <a:pPr>
+              <a:spcAft>
+                <a:spcPts val="600"/>
+              </a:spcAft>
+              <a:defRPr sz="1100">
+                <a:solidFill>
+                  <a:srgbClr val="94A3B8"/>
+                </a:solidFill>
+                <a:latin typeface="Segoe UI"/>
+              </a:defRPr>
+            </a:pPr>
+            <a:r>
+              <a:t>Indicates that the trained model successfully explains ~77.0% of temperature variance on unseen test records.</a:t>
+            </a:r>
+          </a:p>
+          <a:p>
+            <a:pPr>
+              <a:defRPr sz="1300" b="1">
+                <a:solidFill>
+                  <a:srgbClr val="10B981"/>
+                </a:solidFill>
+                <a:latin typeface="Segoe UI"/>
+              </a:defRPr>
+            </a:pPr>
+            <a:r>
+              <a:t>Validation Strategy</a:t>
+            </a:r>
+          </a:p>
+          <a:p>
+            <a:pPr>
+              <a:spcAft>
+                <a:spcPts val="600"/>
+              </a:spcAft>
+              <a:defRPr sz="1100">
+                <a:solidFill>
+                  <a:srgbClr val="94A3B8"/>
+                </a:solidFill>
+                <a:latin typeface="Segoe UI"/>
+              </a:defRPr>
+            </a:pPr>
+            <a:r>
+              <a:t>Tested using out-of-sample data (20% holdout split) to ensure true accuracy scoring rather than training overfitting.</a:t>
+            </a:r>
+          </a:p>
+          <a:p>
+            <a:pPr>
+              <a:defRPr sz="1300" b="1">
+                <a:solidFill>
+                  <a:srgbClr val="10B981"/>
+                </a:solidFill>
+                <a:latin typeface="Segoe UI"/>
+              </a:defRPr>
+            </a:pPr>
+            <a:r>
+              <a:t>Residual Visualizations</a:t>
+            </a:r>
+          </a:p>
+          <a:p>
+            <a:pPr>
+              <a:spcAft>
+                <a:spcPts val="600"/>
+              </a:spcAft>
+              <a:defRPr sz="1100">
+                <a:solidFill>
+                  <a:srgbClr val="94A3B8"/>
+                </a:solidFill>
+                <a:latin typeface="Segoe UI"/>
+              </a:defRPr>
+            </a:pPr>
+            <a:r>
+              <a:t>Validation plots display overlap curves comparing actual temperature cycles with model predictions.</a:t>
             </a:r>
           </a:p>
         </p:txBody>

</xml_diff>